<commit_message>
fix(cohort): remove MRI interval and enter at baseline blood draw
</commit_message>
<xml_diff>
--- a/presentations/CNSRIII_Hcy_WMH_假设驱动统计方案_v2.pptx
+++ b/presentations/CNSRIII_Hcy_WMH_假设驱动统计方案_v2.pptx
@@ -2,40 +2,40 @@
 <file path=ppt/presentation.xml><?xml version="1.0" encoding="utf-8"?>
 <p:presentation xmlns:p="http://schemas.openxmlformats.org/presentationml/2006/main">
   <p:sldMasterIdLst>
-    <p:sldMasterId xmlns:r="http://schemas.openxmlformats.org/officeDocument/2006/relationships" id="2147483648" r:id="R21be0fba848543ce"/>
+    <p:sldMasterId xmlns:r="http://schemas.openxmlformats.org/officeDocument/2006/relationships" id="2147483648" r:id="R75539f5dcfda43d0"/>
   </p:sldMasterIdLst>
   <p:notesMasterIdLst>
-    <p:notesMasterId xmlns:r="http://schemas.openxmlformats.org/officeDocument/2006/relationships" r:id="R8de467e3f3ba45ea"/>
+    <p:notesMasterId xmlns:r="http://schemas.openxmlformats.org/officeDocument/2006/relationships" r:id="R1bc4252b7d394a61"/>
   </p:notesMasterIdLst>
   <p:sldIdLst>
-    <p:sldId xmlns:r="http://schemas.openxmlformats.org/officeDocument/2006/relationships" id="256" r:id="Rdf28e807ca4e49d0"/>
-    <p:sldId xmlns:r="http://schemas.openxmlformats.org/officeDocument/2006/relationships" id="257" r:id="R18c8ef22d2cd46b9"/>
-    <p:sldId xmlns:r="http://schemas.openxmlformats.org/officeDocument/2006/relationships" id="258" r:id="R60fed3feee3b4649"/>
-    <p:sldId xmlns:r="http://schemas.openxmlformats.org/officeDocument/2006/relationships" id="259" r:id="R19d136235c284a7c"/>
-    <p:sldId xmlns:r="http://schemas.openxmlformats.org/officeDocument/2006/relationships" id="260" r:id="Reb7cd1b56c3149eb"/>
-    <p:sldId xmlns:r="http://schemas.openxmlformats.org/officeDocument/2006/relationships" id="261" r:id="R6c8b1d76dab147ee"/>
-    <p:sldId xmlns:r="http://schemas.openxmlformats.org/officeDocument/2006/relationships" id="262" r:id="Raa76a429965a465d"/>
-    <p:sldId xmlns:r="http://schemas.openxmlformats.org/officeDocument/2006/relationships" id="263" r:id="R39c354b451bc471d"/>
-    <p:sldId xmlns:r="http://schemas.openxmlformats.org/officeDocument/2006/relationships" id="264" r:id="Rae1ef740cf924152"/>
-    <p:sldId xmlns:r="http://schemas.openxmlformats.org/officeDocument/2006/relationships" id="265" r:id="R4f750d76c4c34823"/>
-    <p:sldId xmlns:r="http://schemas.openxmlformats.org/officeDocument/2006/relationships" id="266" r:id="Rc8f671710e5f47bf"/>
-    <p:sldId xmlns:r="http://schemas.openxmlformats.org/officeDocument/2006/relationships" id="267" r:id="R9827a92e88604395"/>
-    <p:sldId xmlns:r="http://schemas.openxmlformats.org/officeDocument/2006/relationships" id="268" r:id="Rbcc23cc8e8854df1"/>
-    <p:sldId xmlns:r="http://schemas.openxmlformats.org/officeDocument/2006/relationships" id="269" r:id="R98a59e86550348d3"/>
-    <p:sldId xmlns:r="http://schemas.openxmlformats.org/officeDocument/2006/relationships" id="270" r:id="R80a53912cf884ec8"/>
-    <p:sldId xmlns:r="http://schemas.openxmlformats.org/officeDocument/2006/relationships" id="271" r:id="Rd2c338e2d90441d9"/>
-    <p:sldId xmlns:r="http://schemas.openxmlformats.org/officeDocument/2006/relationships" id="272" r:id="R6c76cbc39d1e4a25"/>
-    <p:sldId xmlns:r="http://schemas.openxmlformats.org/officeDocument/2006/relationships" id="273" r:id="Rda9b10ef37e94a64"/>
-    <p:sldId xmlns:r="http://schemas.openxmlformats.org/officeDocument/2006/relationships" id="274" r:id="R8ed4b4f92f784a86"/>
-    <p:sldId xmlns:r="http://schemas.openxmlformats.org/officeDocument/2006/relationships" id="275" r:id="R04291edd43f34c1a"/>
-    <p:sldId xmlns:r="http://schemas.openxmlformats.org/officeDocument/2006/relationships" id="276" r:id="Rc8f178af27e141e1"/>
-    <p:sldId xmlns:r="http://schemas.openxmlformats.org/officeDocument/2006/relationships" id="277" r:id="R0a2d971ad1df48b8"/>
-    <p:sldId xmlns:r="http://schemas.openxmlformats.org/officeDocument/2006/relationships" id="278" r:id="R2c5722597f444a32"/>
-    <p:sldId xmlns:r="http://schemas.openxmlformats.org/officeDocument/2006/relationships" id="279" r:id="R271db17019d4451e"/>
-    <p:sldId xmlns:r="http://schemas.openxmlformats.org/officeDocument/2006/relationships" id="280" r:id="R454ad0b42ca94d40"/>
-    <p:sldId xmlns:r="http://schemas.openxmlformats.org/officeDocument/2006/relationships" id="281" r:id="R1208960197bc46b6"/>
-    <p:sldId xmlns:r="http://schemas.openxmlformats.org/officeDocument/2006/relationships" id="282" r:id="R4c141fa4342248db"/>
-    <p:sldId xmlns:r="http://schemas.openxmlformats.org/officeDocument/2006/relationships" id="283" r:id="Radc91107bf964970"/>
+    <p:sldId xmlns:r="http://schemas.openxmlformats.org/officeDocument/2006/relationships" id="256" r:id="R758851baa59b4589"/>
+    <p:sldId xmlns:r="http://schemas.openxmlformats.org/officeDocument/2006/relationships" id="257" r:id="R7c5c7cd4476c4b3c"/>
+    <p:sldId xmlns:r="http://schemas.openxmlformats.org/officeDocument/2006/relationships" id="258" r:id="R6e787cd4244c40fe"/>
+    <p:sldId xmlns:r="http://schemas.openxmlformats.org/officeDocument/2006/relationships" id="259" r:id="R05d6b92b766b4834"/>
+    <p:sldId xmlns:r="http://schemas.openxmlformats.org/officeDocument/2006/relationships" id="260" r:id="R6e742b7a92754ce7"/>
+    <p:sldId xmlns:r="http://schemas.openxmlformats.org/officeDocument/2006/relationships" id="261" r:id="Rdc0090f2250944de"/>
+    <p:sldId xmlns:r="http://schemas.openxmlformats.org/officeDocument/2006/relationships" id="262" r:id="R8b5bdaf4e2f84278"/>
+    <p:sldId xmlns:r="http://schemas.openxmlformats.org/officeDocument/2006/relationships" id="263" r:id="R8eee6b0ddb7840d2"/>
+    <p:sldId xmlns:r="http://schemas.openxmlformats.org/officeDocument/2006/relationships" id="264" r:id="Rf6eae2bd6a234563"/>
+    <p:sldId xmlns:r="http://schemas.openxmlformats.org/officeDocument/2006/relationships" id="265" r:id="Rd4e2c4971fb34f23"/>
+    <p:sldId xmlns:r="http://schemas.openxmlformats.org/officeDocument/2006/relationships" id="266" r:id="R6ddbe45af022492a"/>
+    <p:sldId xmlns:r="http://schemas.openxmlformats.org/officeDocument/2006/relationships" id="267" r:id="R146df45574ae43bf"/>
+    <p:sldId xmlns:r="http://schemas.openxmlformats.org/officeDocument/2006/relationships" id="268" r:id="R90a5b06ac5484427"/>
+    <p:sldId xmlns:r="http://schemas.openxmlformats.org/officeDocument/2006/relationships" id="269" r:id="R708edbe6fc1d4389"/>
+    <p:sldId xmlns:r="http://schemas.openxmlformats.org/officeDocument/2006/relationships" id="270" r:id="R6f3d0612d04a4827"/>
+    <p:sldId xmlns:r="http://schemas.openxmlformats.org/officeDocument/2006/relationships" id="271" r:id="R9d522d5ec6b74b86"/>
+    <p:sldId xmlns:r="http://schemas.openxmlformats.org/officeDocument/2006/relationships" id="272" r:id="R4c37a5690ff94e4c"/>
+    <p:sldId xmlns:r="http://schemas.openxmlformats.org/officeDocument/2006/relationships" id="273" r:id="R4970e3fa12a34ebd"/>
+    <p:sldId xmlns:r="http://schemas.openxmlformats.org/officeDocument/2006/relationships" id="274" r:id="Rb436cde82bdc4247"/>
+    <p:sldId xmlns:r="http://schemas.openxmlformats.org/officeDocument/2006/relationships" id="275" r:id="Rd240df7afb254df4"/>
+    <p:sldId xmlns:r="http://schemas.openxmlformats.org/officeDocument/2006/relationships" id="276" r:id="Rc3e92f0dd4604706"/>
+    <p:sldId xmlns:r="http://schemas.openxmlformats.org/officeDocument/2006/relationships" id="277" r:id="R15629b87660f4e30"/>
+    <p:sldId xmlns:r="http://schemas.openxmlformats.org/officeDocument/2006/relationships" id="278" r:id="R29c527bbbb864684"/>
+    <p:sldId xmlns:r="http://schemas.openxmlformats.org/officeDocument/2006/relationships" id="279" r:id="R2d0bfb5332f84fd4"/>
+    <p:sldId xmlns:r="http://schemas.openxmlformats.org/officeDocument/2006/relationships" id="280" r:id="Rccd0a979953d472e"/>
+    <p:sldId xmlns:r="http://schemas.openxmlformats.org/officeDocument/2006/relationships" id="281" r:id="Rcc738dbc73d54ec8"/>
+    <p:sldId xmlns:r="http://schemas.openxmlformats.org/officeDocument/2006/relationships" id="282" r:id="R90acb4183da04a40"/>
+    <p:sldId xmlns:r="http://schemas.openxmlformats.org/officeDocument/2006/relationships" id="283" r:id="R84dc2cc4e8b14a12"/>
   </p:sldIdLst>
   <p:sldSz cx="12192000" cy="6858000"/>
   <p:notesSz cx="6858000" cy="9144000"/>
@@ -832,6 +832,16 @@
               <a:t/>
             </a:r>
           </a:p>
+          <a:p xmlns:a="http://schemas.openxmlformats.org/drawingml/2006/main">
+            <a:r>
+              <a:t/>
+            </a:r>
+          </a:p>
+          <a:p xmlns:a="http://schemas.openxmlformats.org/drawingml/2006/main">
+            <a:r>
+              <a:t>2026-09-16：以发病为时间尺度，从实际基线采血日进入风险集。发病到MRI的天数不再作为输入或筛选条件。合格MRI视为基线结构表型，本分析不核定扫描与早期复发的先后。</a:t>
+            </a:r>
+          </a:p>
         </p:txBody>
       </p:sp>
       <p:sp>
@@ -1139,7 +1149,7 @@
           <a:lstStyle xmlns:a="http://schemas.openxmlformats.org/drawingml/2006/main"/>
           <a:p xmlns:a="http://schemas.openxmlformats.org/drawingml/2006/main">
             <a:r>
-              <a:t>报告从各自测量完成时间起至发病365天的平均风险。相对尺度交互与不同基础风险造成的风险差变化分别解释。</a:t>
+              <a:t>报告从各自基线采血时间起至发病365天的平均风险。相对尺度交互与不同基础风险造成的风险差变化分别解释。</a:t>
             </a:r>
           </a:p>
           <a:p xmlns:a="http://schemas.openxmlformats.org/drawingml/2006/main">
@@ -2997,7 +3007,7 @@
   </p:cSld>
   <p:clrMap bg1="lt1" tx1="dk1" bg2="lt2" tx2="dk2" accent1="accent1" accent2="accent2" accent3="accent3" accent4="accent4" accent5="accent5" accent6="accent6" hlink="hlink" folHlink="folHlink"/>
   <p:sldLayoutIdLst>
-    <p:sldLayoutId xmlns:r="http://schemas.openxmlformats.org/officeDocument/2006/relationships" id="2147483649" r:id="R9ffc7079ea6a4883"/>
+    <p:sldLayoutId xmlns:r="http://schemas.openxmlformats.org/officeDocument/2006/relationships" id="2147483649" r:id="R580b0a5b76644145"/>
   </p:sldLayoutIdLst>
   <p:txStyles>
     <p:titleStyle>
@@ -3577,6 +3587,7 @@
           <a:lstStyle xmlns:a="http://schemas.openxmlformats.org/drawingml/2006/main"/>
           <a:p xmlns:a="http://schemas.openxmlformats.org/drawingml/2006/main">
             <a:pPr>
+              <a:buNone/>
               <a:defRPr sz="1350" b="1">
                 <a:solidFill>
                   <a:srgbClr val="006C70"/>
@@ -3634,6 +3645,7 @@
           <a:lstStyle xmlns:a="http://schemas.openxmlformats.org/drawingml/2006/main"/>
           <a:p xmlns:a="http://schemas.openxmlformats.org/drawingml/2006/main">
             <a:pPr>
+              <a:buNone/>
               <a:defRPr sz="3825" b="1">
                 <a:solidFill>
                   <a:srgbClr val="153040"/>
@@ -3691,6 +3703,7 @@
           <a:lstStyle xmlns:a="http://schemas.openxmlformats.org/drawingml/2006/main"/>
           <a:p xmlns:a="http://schemas.openxmlformats.org/drawingml/2006/main">
             <a:pPr>
+              <a:buNone/>
               <a:defRPr sz="2025" b="0">
                 <a:solidFill>
                   <a:srgbClr val="526872"/>
@@ -3748,6 +3761,7 @@
           <a:lstStyle xmlns:a="http://schemas.openxmlformats.org/drawingml/2006/main"/>
           <a:p xmlns:a="http://schemas.openxmlformats.org/drawingml/2006/main">
             <a:pPr>
+              <a:buNone/>
               <a:defRPr sz="2025" b="1">
                 <a:solidFill>
                   <a:srgbClr val="006C70"/>
@@ -3805,6 +3819,7 @@
           <a:lstStyle xmlns:a="http://schemas.openxmlformats.org/drawingml/2006/main"/>
           <a:p xmlns:a="http://schemas.openxmlformats.org/drawingml/2006/main">
             <a:pPr>
+              <a:buNone/>
               <a:defRPr sz="2100" b="0">
                 <a:solidFill>
                   <a:srgbClr val="153040"/>
@@ -3892,6 +3907,7 @@
           <a:lstStyle xmlns:a="http://schemas.openxmlformats.org/drawingml/2006/main"/>
           <a:p xmlns:a="http://schemas.openxmlformats.org/drawingml/2006/main">
             <a:pPr>
+              <a:buNone/>
               <a:defRPr sz="2025" b="1">
                 <a:solidFill>
                   <a:srgbClr val="006C70"/>
@@ -3949,6 +3965,7 @@
           <a:lstStyle xmlns:a="http://schemas.openxmlformats.org/drawingml/2006/main"/>
           <a:p xmlns:a="http://schemas.openxmlformats.org/drawingml/2006/main">
             <a:pPr>
+              <a:buNone/>
               <a:defRPr sz="2100" b="0">
                 <a:solidFill>
                   <a:srgbClr val="153040"/>
@@ -4036,6 +4053,7 @@
           <a:lstStyle xmlns:a="http://schemas.openxmlformats.org/drawingml/2006/main"/>
           <a:p xmlns:a="http://schemas.openxmlformats.org/drawingml/2006/main">
             <a:pPr>
+              <a:buNone/>
               <a:defRPr sz="2025" b="1">
                 <a:solidFill>
                   <a:srgbClr val="006C70"/>
@@ -4093,6 +4111,7 @@
           <a:lstStyle xmlns:a="http://schemas.openxmlformats.org/drawingml/2006/main"/>
           <a:p xmlns:a="http://schemas.openxmlformats.org/drawingml/2006/main">
             <a:pPr>
+              <a:buNone/>
               <a:defRPr sz="2100" b="0">
                 <a:solidFill>
                   <a:srgbClr val="153040"/>
@@ -4180,6 +4199,7 @@
           <a:lstStyle xmlns:a="http://schemas.openxmlformats.org/drawingml/2006/main"/>
           <a:p xmlns:a="http://schemas.openxmlformats.org/drawingml/2006/main">
             <a:pPr>
+              <a:buNone/>
               <a:defRPr sz="1125" b="0">
                 <a:solidFill>
                   <a:srgbClr val="526872"/>
@@ -4237,6 +4257,7 @@
           <a:lstStyle xmlns:a="http://schemas.openxmlformats.org/drawingml/2006/main"/>
           <a:p xmlns:a="http://schemas.openxmlformats.org/drawingml/2006/main">
             <a:pPr>
+              <a:buNone/>
               <a:defRPr sz="1275" b="0">
                 <a:solidFill>
                   <a:srgbClr val="526872"/>
@@ -4323,6 +4344,7 @@
           <a:lstStyle xmlns:a="http://schemas.openxmlformats.org/drawingml/2006/main"/>
           <a:p xmlns:a="http://schemas.openxmlformats.org/drawingml/2006/main">
             <a:pPr>
+              <a:buNone/>
               <a:defRPr sz="1350" b="1">
                 <a:solidFill>
                   <a:srgbClr val="006C70"/>
@@ -4380,6 +4402,7 @@
           <a:lstStyle xmlns:a="http://schemas.openxmlformats.org/drawingml/2006/main"/>
           <a:p xmlns:a="http://schemas.openxmlformats.org/drawingml/2006/main">
             <a:pPr>
+              <a:buNone/>
               <a:defRPr sz="3225" b="1">
                 <a:solidFill>
                   <a:srgbClr val="153040"/>
@@ -4437,6 +4460,7 @@
           <a:lstStyle xmlns:a="http://schemas.openxmlformats.org/drawingml/2006/main"/>
           <a:p xmlns:a="http://schemas.openxmlformats.org/drawingml/2006/main">
             <a:pPr>
+              <a:buNone/>
               <a:defRPr sz="2025" b="0">
                 <a:solidFill>
                   <a:srgbClr val="526872"/>
@@ -4494,6 +4518,7 @@
           <a:lstStyle xmlns:a="http://schemas.openxmlformats.org/drawingml/2006/main"/>
           <a:p xmlns:a="http://schemas.openxmlformats.org/drawingml/2006/main">
             <a:pPr>
+              <a:buNone/>
               <a:defRPr sz="2025" b="1">
                 <a:solidFill>
                   <a:srgbClr val="006C70"/>
@@ -4551,6 +4576,7 @@
           <a:lstStyle xmlns:a="http://schemas.openxmlformats.org/drawingml/2006/main"/>
           <a:p xmlns:a="http://schemas.openxmlformats.org/drawingml/2006/main">
             <a:pPr>
+              <a:buNone/>
               <a:defRPr sz="2100" b="0">
                 <a:solidFill>
                   <a:srgbClr val="153040"/>
@@ -4638,6 +4664,7 @@
           <a:lstStyle xmlns:a="http://schemas.openxmlformats.org/drawingml/2006/main"/>
           <a:p xmlns:a="http://schemas.openxmlformats.org/drawingml/2006/main">
             <a:pPr>
+              <a:buNone/>
               <a:defRPr sz="2025" b="1">
                 <a:solidFill>
                   <a:srgbClr val="006C70"/>
@@ -4695,6 +4722,7 @@
           <a:lstStyle xmlns:a="http://schemas.openxmlformats.org/drawingml/2006/main"/>
           <a:p xmlns:a="http://schemas.openxmlformats.org/drawingml/2006/main">
             <a:pPr>
+              <a:buNone/>
               <a:defRPr sz="2100" b="0">
                 <a:solidFill>
                   <a:srgbClr val="153040"/>
@@ -4782,6 +4810,7 @@
           <a:lstStyle xmlns:a="http://schemas.openxmlformats.org/drawingml/2006/main"/>
           <a:p xmlns:a="http://schemas.openxmlformats.org/drawingml/2006/main">
             <a:pPr>
+              <a:buNone/>
               <a:defRPr sz="2025" b="1">
                 <a:solidFill>
                   <a:srgbClr val="006C70"/>
@@ -4839,6 +4868,7 @@
           <a:lstStyle xmlns:a="http://schemas.openxmlformats.org/drawingml/2006/main"/>
           <a:p xmlns:a="http://schemas.openxmlformats.org/drawingml/2006/main">
             <a:pPr>
+              <a:buNone/>
               <a:defRPr sz="2100" b="0">
                 <a:solidFill>
                   <a:srgbClr val="153040"/>
@@ -4926,6 +4956,7 @@
           <a:lstStyle xmlns:a="http://schemas.openxmlformats.org/drawingml/2006/main"/>
           <a:p xmlns:a="http://schemas.openxmlformats.org/drawingml/2006/main">
             <a:pPr>
+              <a:buNone/>
               <a:defRPr sz="1125" b="0">
                 <a:solidFill>
                   <a:srgbClr val="526872"/>
@@ -4983,6 +5014,7 @@
           <a:lstStyle xmlns:a="http://schemas.openxmlformats.org/drawingml/2006/main"/>
           <a:p xmlns:a="http://schemas.openxmlformats.org/drawingml/2006/main">
             <a:pPr>
+              <a:buNone/>
               <a:defRPr sz="1275" b="0">
                 <a:solidFill>
                   <a:srgbClr val="526872"/>
@@ -5069,6 +5101,7 @@
           <a:lstStyle xmlns:a="http://schemas.openxmlformats.org/drawingml/2006/main"/>
           <a:p xmlns:a="http://schemas.openxmlformats.org/drawingml/2006/main">
             <a:pPr>
+              <a:buNone/>
               <a:defRPr sz="1350" b="1">
                 <a:solidFill>
                   <a:srgbClr val="006C70"/>
@@ -5126,6 +5159,7 @@
           <a:lstStyle xmlns:a="http://schemas.openxmlformats.org/drawingml/2006/main"/>
           <a:p xmlns:a="http://schemas.openxmlformats.org/drawingml/2006/main">
             <a:pPr>
+              <a:buNone/>
               <a:defRPr sz="3225" b="1">
                 <a:solidFill>
                   <a:srgbClr val="153040"/>
@@ -5183,6 +5217,7 @@
           <a:lstStyle xmlns:a="http://schemas.openxmlformats.org/drawingml/2006/main"/>
           <a:p xmlns:a="http://schemas.openxmlformats.org/drawingml/2006/main">
             <a:pPr>
+              <a:buNone/>
               <a:defRPr sz="2025" b="0">
                 <a:solidFill>
                   <a:srgbClr val="526872"/>
@@ -5244,6 +5279,7 @@
           <a:lstStyle xmlns:a="http://schemas.openxmlformats.org/drawingml/2006/main"/>
           <a:p xmlns:a="http://schemas.openxmlformats.org/drawingml/2006/main">
             <a:pPr algn="ctr">
+              <a:buNone/>
               <a:defRPr sz="1875" b="1">
                 <a:solidFill>
                   <a:srgbClr val="006C70"/>
@@ -5305,6 +5341,7 @@
           <a:lstStyle xmlns:a="http://schemas.openxmlformats.org/drawingml/2006/main"/>
           <a:p xmlns:a="http://schemas.openxmlformats.org/drawingml/2006/main">
             <a:pPr algn="ctr">
+              <a:buNone/>
               <a:defRPr sz="1875" b="1">
                 <a:solidFill>
                   <a:srgbClr val="006C70"/>
@@ -5366,6 +5403,7 @@
           <a:lstStyle xmlns:a="http://schemas.openxmlformats.org/drawingml/2006/main"/>
           <a:p xmlns:a="http://schemas.openxmlformats.org/drawingml/2006/main">
             <a:pPr algn="ctr">
+              <a:buNone/>
               <a:defRPr sz="2025" b="1">
                 <a:solidFill>
                   <a:srgbClr val="006C70"/>
@@ -5427,6 +5465,7 @@
           <a:lstStyle xmlns:a="http://schemas.openxmlformats.org/drawingml/2006/main"/>
           <a:p xmlns:a="http://schemas.openxmlformats.org/drawingml/2006/main">
             <a:pPr algn="ctr">
+              <a:buNone/>
               <a:defRPr sz="1950" b="1">
                 <a:solidFill>
                   <a:srgbClr val="006C70"/>
@@ -5488,6 +5527,7 @@
           <a:lstStyle xmlns:a="http://schemas.openxmlformats.org/drawingml/2006/main"/>
           <a:p xmlns:a="http://schemas.openxmlformats.org/drawingml/2006/main">
             <a:pPr algn="ctr">
+              <a:buNone/>
               <a:defRPr sz="1950" b="1">
                 <a:solidFill>
                   <a:srgbClr val="006C70"/>
@@ -5513,7 +5553,7 @@
       </p:sp>
       <p:cxnSp>
         <p:nvCxnSpPr>
-          <p:cNvPr id="29" name=""/>
+          <p:cNvPr id="45" name=""/>
           <p:cNvCxnSpPr>
             <a:stCxn xmlns:a="http://schemas.openxmlformats.org/drawingml/2006/main" id="4" idx="1"/>
             <a:endCxn xmlns:a="http://schemas.openxmlformats.org/drawingml/2006/main" id="5" idx="0"/>
@@ -5538,7 +5578,7 @@
       </p:cxnSp>
       <p:cxnSp>
         <p:nvCxnSpPr>
-          <p:cNvPr id="30" name=""/>
+          <p:cNvPr id="46" name=""/>
           <p:cNvCxnSpPr>
             <a:stCxn xmlns:a="http://schemas.openxmlformats.org/drawingml/2006/main" id="4" idx="1"/>
             <a:endCxn xmlns:a="http://schemas.openxmlformats.org/drawingml/2006/main" id="6" idx="1"/>
@@ -5563,7 +5603,7 @@
       </p:cxnSp>
       <p:cxnSp>
         <p:nvCxnSpPr>
-          <p:cNvPr id="31" name=""/>
+          <p:cNvPr id="47" name=""/>
           <p:cNvCxnSpPr>
             <a:stCxn xmlns:a="http://schemas.openxmlformats.org/drawingml/2006/main" id="4" idx="3"/>
             <a:endCxn xmlns:a="http://schemas.openxmlformats.org/drawingml/2006/main" id="8" idx="0"/>
@@ -5588,7 +5628,7 @@
       </p:cxnSp>
       <p:cxnSp>
         <p:nvCxnSpPr>
-          <p:cNvPr id="32" name=""/>
+          <p:cNvPr id="48" name=""/>
           <p:cNvCxnSpPr>
             <a:stCxn xmlns:a="http://schemas.openxmlformats.org/drawingml/2006/main" id="5" idx="3"/>
             <a:endCxn xmlns:a="http://schemas.openxmlformats.org/drawingml/2006/main" id="8" idx="1"/>
@@ -5613,7 +5653,7 @@
       </p:cxnSp>
       <p:cxnSp>
         <p:nvCxnSpPr>
-          <p:cNvPr id="33" name=""/>
+          <p:cNvPr id="49" name=""/>
           <p:cNvCxnSpPr>
             <a:stCxn xmlns:a="http://schemas.openxmlformats.org/drawingml/2006/main" id="6" idx="3"/>
             <a:endCxn xmlns:a="http://schemas.openxmlformats.org/drawingml/2006/main" id="8" idx="2"/>
@@ -5638,7 +5678,7 @@
       </p:cxnSp>
       <p:cxnSp>
         <p:nvCxnSpPr>
-          <p:cNvPr id="34" name=""/>
+          <p:cNvPr id="50" name=""/>
           <p:cNvCxnSpPr>
             <a:stCxn xmlns:a="http://schemas.openxmlformats.org/drawingml/2006/main" id="5" idx="2"/>
             <a:endCxn xmlns:a="http://schemas.openxmlformats.org/drawingml/2006/main" id="7" idx="1"/>
@@ -5663,7 +5703,7 @@
       </p:cxnSp>
       <p:cxnSp>
         <p:nvCxnSpPr>
-          <p:cNvPr id="35" name=""/>
+          <p:cNvPr id="51" name=""/>
           <p:cNvCxnSpPr>
             <a:stCxn xmlns:a="http://schemas.openxmlformats.org/drawingml/2006/main" id="6" idx="3"/>
             <a:endCxn xmlns:a="http://schemas.openxmlformats.org/drawingml/2006/main" id="7" idx="1"/>
@@ -5688,7 +5728,7 @@
       </p:cxnSp>
       <p:cxnSp>
         <p:nvCxnSpPr>
-          <p:cNvPr id="36" name=""/>
+          <p:cNvPr id="52" name=""/>
           <p:cNvCxnSpPr>
             <a:stCxn xmlns:a="http://schemas.openxmlformats.org/drawingml/2006/main" id="7" idx="3"/>
             <a:endCxn xmlns:a="http://schemas.openxmlformats.org/drawingml/2006/main" id="8" idx="2"/>
@@ -5745,6 +5785,7 @@
           <a:lstStyle xmlns:a="http://schemas.openxmlformats.org/drawingml/2006/main"/>
           <a:p xmlns:a="http://schemas.openxmlformats.org/drawingml/2006/main">
             <a:pPr>
+              <a:buNone/>
               <a:defRPr sz="1650" b="0">
                 <a:solidFill>
                   <a:srgbClr val="526872"/>
@@ -5832,6 +5873,7 @@
           <a:lstStyle xmlns:a="http://schemas.openxmlformats.org/drawingml/2006/main"/>
           <a:p xmlns:a="http://schemas.openxmlformats.org/drawingml/2006/main">
             <a:pPr>
+              <a:buNone/>
               <a:defRPr sz="1125" b="0">
                 <a:solidFill>
                   <a:srgbClr val="526872"/>
@@ -5889,6 +5931,7 @@
           <a:lstStyle xmlns:a="http://schemas.openxmlformats.org/drawingml/2006/main"/>
           <a:p xmlns:a="http://schemas.openxmlformats.org/drawingml/2006/main">
             <a:pPr>
+              <a:buNone/>
               <a:defRPr sz="1275" b="0">
                 <a:solidFill>
                   <a:srgbClr val="526872"/>
@@ -5975,6 +6018,7 @@
           <a:lstStyle xmlns:a="http://schemas.openxmlformats.org/drawingml/2006/main"/>
           <a:p xmlns:a="http://schemas.openxmlformats.org/drawingml/2006/main">
             <a:pPr>
+              <a:buNone/>
               <a:defRPr sz="1350" b="1">
                 <a:solidFill>
                   <a:srgbClr val="006C70"/>
@@ -6032,6 +6076,7 @@
           <a:lstStyle xmlns:a="http://schemas.openxmlformats.org/drawingml/2006/main"/>
           <a:p xmlns:a="http://schemas.openxmlformats.org/drawingml/2006/main">
             <a:pPr>
+              <a:buNone/>
               <a:defRPr sz="3225" b="1">
                 <a:solidFill>
                   <a:srgbClr val="153040"/>
@@ -6089,6 +6134,7 @@
           <a:lstStyle xmlns:a="http://schemas.openxmlformats.org/drawingml/2006/main"/>
           <a:p xmlns:a="http://schemas.openxmlformats.org/drawingml/2006/main">
             <a:pPr>
+              <a:buNone/>
               <a:defRPr sz="2025" b="0">
                 <a:solidFill>
                   <a:srgbClr val="526872"/>
@@ -6150,6 +6196,7 @@
           <a:lstStyle xmlns:a="http://schemas.openxmlformats.org/drawingml/2006/main"/>
           <a:p xmlns:a="http://schemas.openxmlformats.org/drawingml/2006/main">
             <a:pPr algn="ctr">
+              <a:buNone/>
               <a:defRPr sz="1875" b="1">
                 <a:solidFill>
                   <a:srgbClr val="006C70"/>
@@ -6207,6 +6254,7 @@
           <a:lstStyle xmlns:a="http://schemas.openxmlformats.org/drawingml/2006/main"/>
           <a:p xmlns:a="http://schemas.openxmlformats.org/drawingml/2006/main">
             <a:pPr>
+              <a:buNone/>
               <a:defRPr sz="2100" b="0">
                 <a:solidFill>
                   <a:srgbClr val="153040"/>
@@ -6268,6 +6316,7 @@
           <a:lstStyle xmlns:a="http://schemas.openxmlformats.org/drawingml/2006/main"/>
           <a:p xmlns:a="http://schemas.openxmlformats.org/drawingml/2006/main">
             <a:pPr algn="ctr">
+              <a:buNone/>
               <a:defRPr sz="1875" b="1">
                 <a:solidFill>
                   <a:srgbClr val="006C70"/>
@@ -6293,7 +6342,7 @@
       </p:sp>
       <p:cxnSp>
         <p:nvCxnSpPr>
-          <p:cNvPr id="27" name=""/>
+          <p:cNvPr id="43" name=""/>
           <p:cNvCxnSpPr>
             <a:stCxn xmlns:a="http://schemas.openxmlformats.org/drawingml/2006/main" id="4" idx="2"/>
             <a:endCxn xmlns:a="http://schemas.openxmlformats.org/drawingml/2006/main" id="6" idx="0"/>
@@ -6350,6 +6399,7 @@
           <a:lstStyle xmlns:a="http://schemas.openxmlformats.org/drawingml/2006/main"/>
           <a:p xmlns:a="http://schemas.openxmlformats.org/drawingml/2006/main">
             <a:pPr>
+              <a:buNone/>
               <a:defRPr sz="2100" b="0">
                 <a:solidFill>
                   <a:srgbClr val="153040"/>
@@ -6411,6 +6461,7 @@
           <a:lstStyle xmlns:a="http://schemas.openxmlformats.org/drawingml/2006/main"/>
           <a:p xmlns:a="http://schemas.openxmlformats.org/drawingml/2006/main">
             <a:pPr algn="ctr">
+              <a:buNone/>
               <a:defRPr sz="1875" b="1">
                 <a:solidFill>
                   <a:srgbClr val="006C70"/>
@@ -6436,7 +6487,7 @@
       </p:sp>
       <p:cxnSp>
         <p:nvCxnSpPr>
-          <p:cNvPr id="30" name=""/>
+          <p:cNvPr id="46" name=""/>
           <p:cNvCxnSpPr>
             <a:stCxn xmlns:a="http://schemas.openxmlformats.org/drawingml/2006/main" id="6" idx="2"/>
             <a:endCxn xmlns:a="http://schemas.openxmlformats.org/drawingml/2006/main" id="9" idx="0"/>
@@ -6493,6 +6544,7 @@
           <a:lstStyle xmlns:a="http://schemas.openxmlformats.org/drawingml/2006/main"/>
           <a:p xmlns:a="http://schemas.openxmlformats.org/drawingml/2006/main">
             <a:pPr>
+              <a:buNone/>
               <a:defRPr sz="2100" b="0">
                 <a:solidFill>
                   <a:srgbClr val="153040"/>
@@ -6554,6 +6606,7 @@
           <a:lstStyle xmlns:a="http://schemas.openxmlformats.org/drawingml/2006/main"/>
           <a:p xmlns:a="http://schemas.openxmlformats.org/drawingml/2006/main">
             <a:pPr algn="ctr">
+              <a:buNone/>
               <a:defRPr sz="1875" b="1">
                 <a:solidFill>
                   <a:srgbClr val="006C70"/>
@@ -6579,7 +6632,7 @@
       </p:sp>
       <p:cxnSp>
         <p:nvCxnSpPr>
-          <p:cNvPr id="33" name=""/>
+          <p:cNvPr id="49" name=""/>
           <p:cNvCxnSpPr>
             <a:stCxn xmlns:a="http://schemas.openxmlformats.org/drawingml/2006/main" id="9" idx="2"/>
             <a:endCxn xmlns:a="http://schemas.openxmlformats.org/drawingml/2006/main" id="12" idx="0"/>
@@ -6636,6 +6689,7 @@
           <a:lstStyle xmlns:a="http://schemas.openxmlformats.org/drawingml/2006/main"/>
           <a:p xmlns:a="http://schemas.openxmlformats.org/drawingml/2006/main">
             <a:pPr>
+              <a:buNone/>
               <a:defRPr sz="2100" b="0">
                 <a:solidFill>
                   <a:srgbClr val="153040"/>
@@ -6697,6 +6751,7 @@
           <a:lstStyle xmlns:a="http://schemas.openxmlformats.org/drawingml/2006/main"/>
           <a:p xmlns:a="http://schemas.openxmlformats.org/drawingml/2006/main">
             <a:pPr algn="ctr">
+              <a:buNone/>
               <a:defRPr sz="1875" b="1">
                 <a:solidFill>
                   <a:srgbClr val="006C70"/>
@@ -6722,7 +6777,7 @@
       </p:sp>
       <p:cxnSp>
         <p:nvCxnSpPr>
-          <p:cNvPr id="36" name=""/>
+          <p:cNvPr id="52" name=""/>
           <p:cNvCxnSpPr>
             <a:stCxn xmlns:a="http://schemas.openxmlformats.org/drawingml/2006/main" id="12" idx="2"/>
             <a:endCxn xmlns:a="http://schemas.openxmlformats.org/drawingml/2006/main" id="15" idx="0"/>
@@ -6779,6 +6834,7 @@
           <a:lstStyle xmlns:a="http://schemas.openxmlformats.org/drawingml/2006/main"/>
           <a:p xmlns:a="http://schemas.openxmlformats.org/drawingml/2006/main">
             <a:pPr>
+              <a:buNone/>
               <a:defRPr sz="2100" b="0">
                 <a:solidFill>
                   <a:srgbClr val="153040"/>
@@ -6866,6 +6922,7 @@
           <a:lstStyle xmlns:a="http://schemas.openxmlformats.org/drawingml/2006/main"/>
           <a:p xmlns:a="http://schemas.openxmlformats.org/drawingml/2006/main">
             <a:pPr>
+              <a:buNone/>
               <a:defRPr sz="1125" b="0">
                 <a:solidFill>
                   <a:srgbClr val="526872"/>
@@ -6923,6 +6980,7 @@
           <a:lstStyle xmlns:a="http://schemas.openxmlformats.org/drawingml/2006/main"/>
           <a:p xmlns:a="http://schemas.openxmlformats.org/drawingml/2006/main">
             <a:pPr>
+              <a:buNone/>
               <a:defRPr sz="1275" b="0">
                 <a:solidFill>
                   <a:srgbClr val="526872"/>
@@ -7009,6 +7067,7 @@
           <a:lstStyle xmlns:a="http://schemas.openxmlformats.org/drawingml/2006/main"/>
           <a:p xmlns:a="http://schemas.openxmlformats.org/drawingml/2006/main">
             <a:pPr>
+              <a:buNone/>
               <a:defRPr sz="1350" b="1">
                 <a:solidFill>
                   <a:srgbClr val="006C70"/>
@@ -7066,6 +7125,7 @@
           <a:lstStyle xmlns:a="http://schemas.openxmlformats.org/drawingml/2006/main"/>
           <a:p xmlns:a="http://schemas.openxmlformats.org/drawingml/2006/main">
             <a:pPr>
+              <a:buNone/>
               <a:defRPr sz="3225" b="1">
                 <a:solidFill>
                   <a:srgbClr val="153040"/>
@@ -7123,6 +7183,7 @@
           <a:lstStyle xmlns:a="http://schemas.openxmlformats.org/drawingml/2006/main"/>
           <a:p xmlns:a="http://schemas.openxmlformats.org/drawingml/2006/main">
             <a:pPr>
+              <a:buNone/>
               <a:defRPr sz="2025" b="0">
                 <a:solidFill>
                   <a:srgbClr val="526872"/>
@@ -7141,7 +7202,7 @@
                 <a:ea typeface="Microsoft YaHei"/>
                 <a:cs typeface="Microsoft YaHei"/>
               </a:rPr>
-              <a:t>主分析保留测量完成后、三个月以内发生的复发。</a:t>
+              <a:t>主分析保留基线采血后、三个月以内发生的复发。</a:t>
             </a:r>
           </a:p>
         </p:txBody>
@@ -7184,6 +7245,7 @@
           <a:lstStyle xmlns:a="http://schemas.openxmlformats.org/drawingml/2006/main"/>
           <a:p xmlns:a="http://schemas.openxmlformats.org/drawingml/2006/main">
             <a:pPr algn="ctr">
+              <a:buNone/>
               <a:defRPr sz="2100" b="1">
                 <a:solidFill>
                   <a:srgbClr val="006C70"/>
@@ -7241,6 +7303,7 @@
           <a:lstStyle xmlns:a="http://schemas.openxmlformats.org/drawingml/2006/main"/>
           <a:p xmlns:a="http://schemas.openxmlformats.org/drawingml/2006/main">
             <a:pPr>
+              <a:buNone/>
               <a:defRPr sz="1800" b="0">
                 <a:solidFill>
                   <a:srgbClr val="153040"/>
@@ -7302,6 +7365,7 @@
           <a:lstStyle xmlns:a="http://schemas.openxmlformats.org/drawingml/2006/main"/>
           <a:p xmlns:a="http://schemas.openxmlformats.org/drawingml/2006/main">
             <a:pPr algn="ctr">
+              <a:buNone/>
               <a:defRPr sz="2100" b="1">
                 <a:solidFill>
                   <a:srgbClr val="006C70"/>
@@ -7320,7 +7384,7 @@
                 <a:ea typeface="Microsoft YaHei"/>
                 <a:cs typeface="Microsoft YaHei"/>
               </a:rPr>
-              <a:t>完成血样+MRI</a:t>
+              <a:t>基线采血</a:t>
             </a:r>
           </a:p>
         </p:txBody>
@@ -7359,6 +7423,7 @@
           <a:lstStyle xmlns:a="http://schemas.openxmlformats.org/drawingml/2006/main"/>
           <a:p xmlns:a="http://schemas.openxmlformats.org/drawingml/2006/main">
             <a:pPr>
+              <a:buNone/>
               <a:defRPr sz="1800" b="0">
                 <a:solidFill>
                   <a:srgbClr val="153040"/>
@@ -7384,7 +7449,7 @@
       </p:sp>
       <p:cxnSp>
         <p:nvCxnSpPr>
-          <p:cNvPr id="28" name=""/>
+          <p:cNvPr id="42" name=""/>
           <p:cNvCxnSpPr>
             <a:stCxn xmlns:a="http://schemas.openxmlformats.org/drawingml/2006/main" id="4" idx="3"/>
             <a:endCxn xmlns:a="http://schemas.openxmlformats.org/drawingml/2006/main" id="6" idx="1"/>
@@ -7445,6 +7510,7 @@
           <a:lstStyle xmlns:a="http://schemas.openxmlformats.org/drawingml/2006/main"/>
           <a:p xmlns:a="http://schemas.openxmlformats.org/drawingml/2006/main">
             <a:pPr algn="ctr">
+              <a:buNone/>
               <a:defRPr sz="2100" b="1">
                 <a:solidFill>
                   <a:srgbClr val="006C70"/>
@@ -7502,6 +7568,7 @@
           <a:lstStyle xmlns:a="http://schemas.openxmlformats.org/drawingml/2006/main"/>
           <a:p xmlns:a="http://schemas.openxmlformats.org/drawingml/2006/main">
             <a:pPr>
+              <a:buNone/>
               <a:defRPr sz="1800" b="0">
                 <a:solidFill>
                   <a:srgbClr val="153040"/>
@@ -7527,7 +7594,7 @@
       </p:sp>
       <p:cxnSp>
         <p:nvCxnSpPr>
-          <p:cNvPr id="31" name=""/>
+          <p:cNvPr id="45" name=""/>
           <p:cNvCxnSpPr>
             <a:stCxn xmlns:a="http://schemas.openxmlformats.org/drawingml/2006/main" id="6" idx="3"/>
             <a:endCxn xmlns:a="http://schemas.openxmlformats.org/drawingml/2006/main" id="9" idx="1"/>
@@ -7588,6 +7655,7 @@
           <a:lstStyle xmlns:a="http://schemas.openxmlformats.org/drawingml/2006/main"/>
           <a:p xmlns:a="http://schemas.openxmlformats.org/drawingml/2006/main">
             <a:pPr algn="ctr">
+              <a:buNone/>
               <a:defRPr sz="2100" b="1">
                 <a:solidFill>
                   <a:srgbClr val="006C70"/>
@@ -7645,6 +7713,7 @@
           <a:lstStyle xmlns:a="http://schemas.openxmlformats.org/drawingml/2006/main"/>
           <a:p xmlns:a="http://schemas.openxmlformats.org/drawingml/2006/main">
             <a:pPr>
+              <a:buNone/>
               <a:defRPr sz="1800" b="0">
                 <a:solidFill>
                   <a:srgbClr val="153040"/>
@@ -7670,7 +7739,7 @@
       </p:sp>
       <p:cxnSp>
         <p:nvCxnSpPr>
-          <p:cNvPr id="34" name=""/>
+          <p:cNvPr id="48" name=""/>
           <p:cNvCxnSpPr>
             <a:stCxn xmlns:a="http://schemas.openxmlformats.org/drawingml/2006/main" id="9" idx="3"/>
             <a:endCxn xmlns:a="http://schemas.openxmlformats.org/drawingml/2006/main" id="12" idx="1"/>
@@ -7757,6 +7826,7 @@
           <a:lstStyle xmlns:a="http://schemas.openxmlformats.org/drawingml/2006/main"/>
           <a:p xmlns:a="http://schemas.openxmlformats.org/drawingml/2006/main">
             <a:pPr>
+              <a:buNone/>
               <a:defRPr sz="2100" b="1">
                 <a:solidFill>
                   <a:srgbClr val="006C70"/>
@@ -7814,6 +7884,7 @@
           <a:lstStyle xmlns:a="http://schemas.openxmlformats.org/drawingml/2006/main"/>
           <a:p xmlns:a="http://schemas.openxmlformats.org/drawingml/2006/main">
             <a:pPr>
+              <a:buNone/>
               <a:defRPr sz="2100" b="0">
                 <a:solidFill>
                   <a:srgbClr val="153040"/>
@@ -7832,7 +7903,7 @@
                 <a:ea typeface="Microsoft YaHei"/>
                 <a:cs typeface="Microsoft YaHei"/>
               </a:rPr>
-              <a:t>测量完成后至M3之前的事件计入H2；H3使用采血时仍存活且无复发者。</a:t>
+              <a:t>采血后至M3之前的复发计入H2；H3纳入M3采血时仍存活且无复发者。</a:t>
             </a:r>
           </a:p>
         </p:txBody>
@@ -7901,6 +7972,7 @@
           <a:lstStyle xmlns:a="http://schemas.openxmlformats.org/drawingml/2006/main"/>
           <a:p xmlns:a="http://schemas.openxmlformats.org/drawingml/2006/main">
             <a:pPr>
+              <a:buNone/>
               <a:defRPr sz="1125" b="0">
                 <a:solidFill>
                   <a:srgbClr val="526872"/>
@@ -7958,6 +8030,7 @@
           <a:lstStyle xmlns:a="http://schemas.openxmlformats.org/drawingml/2006/main"/>
           <a:p xmlns:a="http://schemas.openxmlformats.org/drawingml/2006/main">
             <a:pPr>
+              <a:buNone/>
               <a:defRPr sz="1275" b="0">
                 <a:solidFill>
                   <a:srgbClr val="526872"/>
@@ -8044,6 +8117,7 @@
           <a:lstStyle xmlns:a="http://schemas.openxmlformats.org/drawingml/2006/main"/>
           <a:p xmlns:a="http://schemas.openxmlformats.org/drawingml/2006/main">
             <a:pPr>
+              <a:buNone/>
               <a:defRPr sz="1350" b="1">
                 <a:solidFill>
                   <a:srgbClr val="006C70"/>
@@ -8101,6 +8175,7 @@
           <a:lstStyle xmlns:a="http://schemas.openxmlformats.org/drawingml/2006/main"/>
           <a:p xmlns:a="http://schemas.openxmlformats.org/drawingml/2006/main">
             <a:pPr>
+              <a:buNone/>
               <a:defRPr sz="3225" b="1">
                 <a:solidFill>
                   <a:srgbClr val="153040"/>
@@ -8158,6 +8233,7 @@
           <a:lstStyle xmlns:a="http://schemas.openxmlformats.org/drawingml/2006/main"/>
           <a:p xmlns:a="http://schemas.openxmlformats.org/drawingml/2006/main">
             <a:pPr>
+              <a:buNone/>
               <a:defRPr sz="2025" b="0">
                 <a:solidFill>
                   <a:srgbClr val="526872"/>
@@ -8176,14 +8252,14 @@
                 <a:ea typeface="Microsoft YaHei"/>
                 <a:cs typeface="Microsoft YaHei"/>
               </a:rPr>
-              <a:t>39个临床来源字段维持白名单；影像接入全掩膜体积。</a:t>
+              <a:t>38个临床来源字段维持白名单；影像接入全掩膜体积。</a:t>
             </a:r>
           </a:p>
         </p:txBody>
       </p:sp>
       <p:graphicFrame>
         <p:nvGraphicFramePr>
-          <p:cNvPr id="11" name=""/>
+          <p:cNvPr id="13" name=""/>
           <p:cNvGraphicFramePr/>
           <p:nvPr/>
         </p:nvGraphicFramePr>
@@ -8668,6 +8744,7 @@
           <a:lstStyle xmlns:a="http://schemas.openxmlformats.org/drawingml/2006/main"/>
           <a:p xmlns:a="http://schemas.openxmlformats.org/drawingml/2006/main">
             <a:pPr>
+              <a:buNone/>
               <a:defRPr sz="1125" b="0">
                 <a:solidFill>
                   <a:srgbClr val="526872"/>
@@ -8725,6 +8802,7 @@
           <a:lstStyle xmlns:a="http://schemas.openxmlformats.org/drawingml/2006/main"/>
           <a:p xmlns:a="http://schemas.openxmlformats.org/drawingml/2006/main">
             <a:pPr>
+              <a:buNone/>
               <a:defRPr sz="1275" b="0">
                 <a:solidFill>
                   <a:srgbClr val="526872"/>
@@ -8811,6 +8889,7 @@
           <a:lstStyle xmlns:a="http://schemas.openxmlformats.org/drawingml/2006/main"/>
           <a:p xmlns:a="http://schemas.openxmlformats.org/drawingml/2006/main">
             <a:pPr>
+              <a:buNone/>
               <a:defRPr sz="1350" b="1">
                 <a:solidFill>
                   <a:srgbClr val="006C70"/>
@@ -8868,6 +8947,7 @@
           <a:lstStyle xmlns:a="http://schemas.openxmlformats.org/drawingml/2006/main"/>
           <a:p xmlns:a="http://schemas.openxmlformats.org/drawingml/2006/main">
             <a:pPr>
+              <a:buNone/>
               <a:defRPr sz="3225" b="1">
                 <a:solidFill>
                   <a:srgbClr val="153040"/>
@@ -8925,6 +9005,7 @@
           <a:lstStyle xmlns:a="http://schemas.openxmlformats.org/drawingml/2006/main"/>
           <a:p xmlns:a="http://schemas.openxmlformats.org/drawingml/2006/main">
             <a:pPr>
+              <a:buNone/>
               <a:defRPr sz="2025" b="0">
                 <a:solidFill>
                   <a:srgbClr val="526872"/>
@@ -8982,6 +9063,7 @@
           <a:lstStyle xmlns:a="http://schemas.openxmlformats.org/drawingml/2006/main"/>
           <a:p xmlns:a="http://schemas.openxmlformats.org/drawingml/2006/main">
             <a:pPr>
+              <a:buNone/>
               <a:defRPr sz="2025" b="1">
                 <a:solidFill>
                   <a:srgbClr val="006C70"/>
@@ -9039,6 +9121,7 @@
           <a:lstStyle xmlns:a="http://schemas.openxmlformats.org/drawingml/2006/main"/>
           <a:p xmlns:a="http://schemas.openxmlformats.org/drawingml/2006/main">
             <a:pPr>
+              <a:buNone/>
               <a:defRPr sz="2100" b="0">
                 <a:solidFill>
                   <a:srgbClr val="153040"/>
@@ -9126,6 +9209,7 @@
           <a:lstStyle xmlns:a="http://schemas.openxmlformats.org/drawingml/2006/main"/>
           <a:p xmlns:a="http://schemas.openxmlformats.org/drawingml/2006/main">
             <a:pPr>
+              <a:buNone/>
               <a:defRPr sz="2025" b="1">
                 <a:solidFill>
                   <a:srgbClr val="006C70"/>
@@ -9183,6 +9267,7 @@
           <a:lstStyle xmlns:a="http://schemas.openxmlformats.org/drawingml/2006/main"/>
           <a:p xmlns:a="http://schemas.openxmlformats.org/drawingml/2006/main">
             <a:pPr>
+              <a:buNone/>
               <a:defRPr sz="2100" b="0">
                 <a:solidFill>
                   <a:srgbClr val="153040"/>
@@ -9270,6 +9355,7 @@
           <a:lstStyle xmlns:a="http://schemas.openxmlformats.org/drawingml/2006/main"/>
           <a:p xmlns:a="http://schemas.openxmlformats.org/drawingml/2006/main">
             <a:pPr>
+              <a:buNone/>
               <a:defRPr sz="2025" b="1">
                 <a:solidFill>
                   <a:srgbClr val="006C70"/>
@@ -9327,6 +9413,7 @@
           <a:lstStyle xmlns:a="http://schemas.openxmlformats.org/drawingml/2006/main"/>
           <a:p xmlns:a="http://schemas.openxmlformats.org/drawingml/2006/main">
             <a:pPr>
+              <a:buNone/>
               <a:defRPr sz="2100" b="0">
                 <a:solidFill>
                   <a:srgbClr val="153040"/>
@@ -9414,6 +9501,7 @@
           <a:lstStyle xmlns:a="http://schemas.openxmlformats.org/drawingml/2006/main"/>
           <a:p xmlns:a="http://schemas.openxmlformats.org/drawingml/2006/main">
             <a:pPr>
+              <a:buNone/>
               <a:defRPr sz="1125" b="0">
                 <a:solidFill>
                   <a:srgbClr val="526872"/>
@@ -9471,6 +9559,7 @@
           <a:lstStyle xmlns:a="http://schemas.openxmlformats.org/drawingml/2006/main"/>
           <a:p xmlns:a="http://schemas.openxmlformats.org/drawingml/2006/main">
             <a:pPr>
+              <a:buNone/>
               <a:defRPr sz="1275" b="0">
                 <a:solidFill>
                   <a:srgbClr val="526872"/>
@@ -9557,6 +9646,7 @@
           <a:lstStyle xmlns:a="http://schemas.openxmlformats.org/drawingml/2006/main"/>
           <a:p xmlns:a="http://schemas.openxmlformats.org/drawingml/2006/main">
             <a:pPr>
+              <a:buNone/>
               <a:defRPr sz="1350" b="1">
                 <a:solidFill>
                   <a:srgbClr val="006C70"/>
@@ -9614,6 +9704,7 @@
           <a:lstStyle xmlns:a="http://schemas.openxmlformats.org/drawingml/2006/main"/>
           <a:p xmlns:a="http://schemas.openxmlformats.org/drawingml/2006/main">
             <a:pPr>
+              <a:buNone/>
               <a:defRPr sz="3225" b="1">
                 <a:solidFill>
                   <a:srgbClr val="153040"/>
@@ -9671,6 +9762,7 @@
           <a:lstStyle xmlns:a="http://schemas.openxmlformats.org/drawingml/2006/main"/>
           <a:p xmlns:a="http://schemas.openxmlformats.org/drawingml/2006/main">
             <a:pPr>
+              <a:buNone/>
               <a:defRPr sz="2025" b="0">
                 <a:solidFill>
                   <a:srgbClr val="526872"/>
@@ -9728,6 +9820,7 @@
           <a:lstStyle xmlns:a="http://schemas.openxmlformats.org/drawingml/2006/main"/>
           <a:p xmlns:a="http://schemas.openxmlformats.org/drawingml/2006/main">
             <a:pPr>
+              <a:buNone/>
               <a:defRPr sz="2025" b="1">
                 <a:solidFill>
                   <a:srgbClr val="006C70"/>
@@ -9785,6 +9878,7 @@
           <a:lstStyle xmlns:a="http://schemas.openxmlformats.org/drawingml/2006/main"/>
           <a:p xmlns:a="http://schemas.openxmlformats.org/drawingml/2006/main">
             <a:pPr>
+              <a:buNone/>
               <a:defRPr sz="2100" b="0">
                 <a:solidFill>
                   <a:srgbClr val="153040"/>
@@ -9872,6 +9966,7 @@
           <a:lstStyle xmlns:a="http://schemas.openxmlformats.org/drawingml/2006/main"/>
           <a:p xmlns:a="http://schemas.openxmlformats.org/drawingml/2006/main">
             <a:pPr>
+              <a:buNone/>
               <a:defRPr sz="2025" b="1">
                 <a:solidFill>
                   <a:srgbClr val="006C70"/>
@@ -9929,6 +10024,7 @@
           <a:lstStyle xmlns:a="http://schemas.openxmlformats.org/drawingml/2006/main"/>
           <a:p xmlns:a="http://schemas.openxmlformats.org/drawingml/2006/main">
             <a:pPr>
+              <a:buNone/>
               <a:defRPr sz="2100" b="0">
                 <a:solidFill>
                   <a:srgbClr val="153040"/>
@@ -10016,6 +10112,7 @@
           <a:lstStyle xmlns:a="http://schemas.openxmlformats.org/drawingml/2006/main"/>
           <a:p xmlns:a="http://schemas.openxmlformats.org/drawingml/2006/main">
             <a:pPr>
+              <a:buNone/>
               <a:defRPr sz="2025" b="1">
                 <a:solidFill>
                   <a:srgbClr val="006C70"/>
@@ -10073,6 +10170,7 @@
           <a:lstStyle xmlns:a="http://schemas.openxmlformats.org/drawingml/2006/main"/>
           <a:p xmlns:a="http://schemas.openxmlformats.org/drawingml/2006/main">
             <a:pPr>
+              <a:buNone/>
               <a:defRPr sz="2100" b="0">
                 <a:solidFill>
                   <a:srgbClr val="153040"/>
@@ -10160,6 +10258,7 @@
           <a:lstStyle xmlns:a="http://schemas.openxmlformats.org/drawingml/2006/main"/>
           <a:p xmlns:a="http://schemas.openxmlformats.org/drawingml/2006/main">
             <a:pPr>
+              <a:buNone/>
               <a:defRPr sz="1125" b="0">
                 <a:solidFill>
                   <a:srgbClr val="526872"/>
@@ -10217,6 +10316,7 @@
           <a:lstStyle xmlns:a="http://schemas.openxmlformats.org/drawingml/2006/main"/>
           <a:p xmlns:a="http://schemas.openxmlformats.org/drawingml/2006/main">
             <a:pPr>
+              <a:buNone/>
               <a:defRPr sz="1275" b="0">
                 <a:solidFill>
                   <a:srgbClr val="526872"/>
@@ -10303,6 +10403,7 @@
           <a:lstStyle xmlns:a="http://schemas.openxmlformats.org/drawingml/2006/main"/>
           <a:p xmlns:a="http://schemas.openxmlformats.org/drawingml/2006/main">
             <a:pPr>
+              <a:buNone/>
               <a:defRPr sz="1350" b="1">
                 <a:solidFill>
                   <a:srgbClr val="006C70"/>
@@ -10360,6 +10461,7 @@
           <a:lstStyle xmlns:a="http://schemas.openxmlformats.org/drawingml/2006/main"/>
           <a:p xmlns:a="http://schemas.openxmlformats.org/drawingml/2006/main">
             <a:pPr>
+              <a:buNone/>
               <a:defRPr sz="3225" b="1">
                 <a:solidFill>
                   <a:srgbClr val="153040"/>
@@ -10417,6 +10519,7 @@
           <a:lstStyle xmlns:a="http://schemas.openxmlformats.org/drawingml/2006/main"/>
           <a:p xmlns:a="http://schemas.openxmlformats.org/drawingml/2006/main">
             <a:pPr>
+              <a:buNone/>
               <a:defRPr sz="2025" b="0">
                 <a:solidFill>
                   <a:srgbClr val="526872"/>
@@ -10474,6 +10577,7 @@
           <a:lstStyle xmlns:a="http://schemas.openxmlformats.org/drawingml/2006/main"/>
           <a:p xmlns:a="http://schemas.openxmlformats.org/drawingml/2006/main">
             <a:pPr>
+              <a:buNone/>
               <a:defRPr sz="2025" b="1">
                 <a:solidFill>
                   <a:srgbClr val="006C70"/>
@@ -10531,6 +10635,7 @@
           <a:lstStyle xmlns:a="http://schemas.openxmlformats.org/drawingml/2006/main"/>
           <a:p xmlns:a="http://schemas.openxmlformats.org/drawingml/2006/main">
             <a:pPr>
+              <a:buNone/>
               <a:defRPr sz="2100" b="0">
                 <a:solidFill>
                   <a:srgbClr val="153040"/>
@@ -10618,6 +10723,7 @@
           <a:lstStyle xmlns:a="http://schemas.openxmlformats.org/drawingml/2006/main"/>
           <a:p xmlns:a="http://schemas.openxmlformats.org/drawingml/2006/main">
             <a:pPr>
+              <a:buNone/>
               <a:defRPr sz="2025" b="1">
                 <a:solidFill>
                   <a:srgbClr val="006C70"/>
@@ -10675,6 +10781,7 @@
           <a:lstStyle xmlns:a="http://schemas.openxmlformats.org/drawingml/2006/main"/>
           <a:p xmlns:a="http://schemas.openxmlformats.org/drawingml/2006/main">
             <a:pPr>
+              <a:buNone/>
               <a:defRPr sz="2100" b="0">
                 <a:solidFill>
                   <a:srgbClr val="153040"/>
@@ -10762,6 +10869,7 @@
           <a:lstStyle xmlns:a="http://schemas.openxmlformats.org/drawingml/2006/main"/>
           <a:p xmlns:a="http://schemas.openxmlformats.org/drawingml/2006/main">
             <a:pPr>
+              <a:buNone/>
               <a:defRPr sz="2025" b="1">
                 <a:solidFill>
                   <a:srgbClr val="006C70"/>
@@ -10819,6 +10927,7 @@
           <a:lstStyle xmlns:a="http://schemas.openxmlformats.org/drawingml/2006/main"/>
           <a:p xmlns:a="http://schemas.openxmlformats.org/drawingml/2006/main">
             <a:pPr>
+              <a:buNone/>
               <a:defRPr sz="2100" b="0">
                 <a:solidFill>
                   <a:srgbClr val="153040"/>
@@ -10906,6 +11015,7 @@
           <a:lstStyle xmlns:a="http://schemas.openxmlformats.org/drawingml/2006/main"/>
           <a:p xmlns:a="http://schemas.openxmlformats.org/drawingml/2006/main">
             <a:pPr>
+              <a:buNone/>
               <a:defRPr sz="1125" b="0">
                 <a:solidFill>
                   <a:srgbClr val="526872"/>
@@ -10963,6 +11073,7 @@
           <a:lstStyle xmlns:a="http://schemas.openxmlformats.org/drawingml/2006/main"/>
           <a:p xmlns:a="http://schemas.openxmlformats.org/drawingml/2006/main">
             <a:pPr>
+              <a:buNone/>
               <a:defRPr sz="1275" b="0">
                 <a:solidFill>
                   <a:srgbClr val="526872"/>
@@ -11049,6 +11160,7 @@
           <a:lstStyle xmlns:a="http://schemas.openxmlformats.org/drawingml/2006/main"/>
           <a:p xmlns:a="http://schemas.openxmlformats.org/drawingml/2006/main">
             <a:pPr>
+              <a:buNone/>
               <a:defRPr sz="1350" b="1">
                 <a:solidFill>
                   <a:srgbClr val="006C70"/>
@@ -11106,6 +11218,7 @@
           <a:lstStyle xmlns:a="http://schemas.openxmlformats.org/drawingml/2006/main"/>
           <a:p xmlns:a="http://schemas.openxmlformats.org/drawingml/2006/main">
             <a:pPr>
+              <a:buNone/>
               <a:defRPr sz="3225" b="1">
                 <a:solidFill>
                   <a:srgbClr val="153040"/>
@@ -11163,6 +11276,7 @@
           <a:lstStyle xmlns:a="http://schemas.openxmlformats.org/drawingml/2006/main"/>
           <a:p xmlns:a="http://schemas.openxmlformats.org/drawingml/2006/main">
             <a:pPr>
+              <a:buNone/>
               <a:defRPr sz="2025" b="0">
                 <a:solidFill>
                   <a:srgbClr val="526872"/>
@@ -11220,6 +11334,7 @@
           <a:lstStyle xmlns:a="http://schemas.openxmlformats.org/drawingml/2006/main"/>
           <a:p xmlns:a="http://schemas.openxmlformats.org/drawingml/2006/main">
             <a:pPr>
+              <a:buNone/>
               <a:defRPr sz="2025" b="1">
                 <a:solidFill>
                   <a:srgbClr val="006C70"/>
@@ -11277,6 +11392,7 @@
           <a:lstStyle xmlns:a="http://schemas.openxmlformats.org/drawingml/2006/main"/>
           <a:p xmlns:a="http://schemas.openxmlformats.org/drawingml/2006/main">
             <a:pPr>
+              <a:buNone/>
               <a:defRPr sz="2100" b="0">
                 <a:solidFill>
                   <a:srgbClr val="153040"/>
@@ -11364,6 +11480,7 @@
           <a:lstStyle xmlns:a="http://schemas.openxmlformats.org/drawingml/2006/main"/>
           <a:p xmlns:a="http://schemas.openxmlformats.org/drawingml/2006/main">
             <a:pPr>
+              <a:buNone/>
               <a:defRPr sz="2025" b="1">
                 <a:solidFill>
                   <a:srgbClr val="006C70"/>
@@ -11421,6 +11538,7 @@
           <a:lstStyle xmlns:a="http://schemas.openxmlformats.org/drawingml/2006/main"/>
           <a:p xmlns:a="http://schemas.openxmlformats.org/drawingml/2006/main">
             <a:pPr>
+              <a:buNone/>
               <a:defRPr sz="2100" b="0">
                 <a:solidFill>
                   <a:srgbClr val="153040"/>
@@ -11508,6 +11626,7 @@
           <a:lstStyle xmlns:a="http://schemas.openxmlformats.org/drawingml/2006/main"/>
           <a:p xmlns:a="http://schemas.openxmlformats.org/drawingml/2006/main">
             <a:pPr>
+              <a:buNone/>
               <a:defRPr sz="2025" b="1">
                 <a:solidFill>
                   <a:srgbClr val="006C70"/>
@@ -11565,6 +11684,7 @@
           <a:lstStyle xmlns:a="http://schemas.openxmlformats.org/drawingml/2006/main"/>
           <a:p xmlns:a="http://schemas.openxmlformats.org/drawingml/2006/main">
             <a:pPr>
+              <a:buNone/>
               <a:defRPr sz="2100" b="0">
                 <a:solidFill>
                   <a:srgbClr val="153040"/>
@@ -11652,6 +11772,7 @@
           <a:lstStyle xmlns:a="http://schemas.openxmlformats.org/drawingml/2006/main"/>
           <a:p xmlns:a="http://schemas.openxmlformats.org/drawingml/2006/main">
             <a:pPr>
+              <a:buNone/>
               <a:defRPr sz="1125" b="0">
                 <a:solidFill>
                   <a:srgbClr val="526872"/>
@@ -11709,6 +11830,7 @@
           <a:lstStyle xmlns:a="http://schemas.openxmlformats.org/drawingml/2006/main"/>
           <a:p xmlns:a="http://schemas.openxmlformats.org/drawingml/2006/main">
             <a:pPr>
+              <a:buNone/>
               <a:defRPr sz="1275" b="0">
                 <a:solidFill>
                   <a:srgbClr val="526872"/>
@@ -11795,6 +11917,7 @@
           <a:lstStyle xmlns:a="http://schemas.openxmlformats.org/drawingml/2006/main"/>
           <a:p xmlns:a="http://schemas.openxmlformats.org/drawingml/2006/main">
             <a:pPr>
+              <a:buNone/>
               <a:defRPr sz="1350" b="1">
                 <a:solidFill>
                   <a:srgbClr val="006C70"/>
@@ -11852,6 +11975,7 @@
           <a:lstStyle xmlns:a="http://schemas.openxmlformats.org/drawingml/2006/main"/>
           <a:p xmlns:a="http://schemas.openxmlformats.org/drawingml/2006/main">
             <a:pPr>
+              <a:buNone/>
               <a:defRPr sz="3225" b="1">
                 <a:solidFill>
                   <a:srgbClr val="153040"/>
@@ -11909,6 +12033,7 @@
           <a:lstStyle xmlns:a="http://schemas.openxmlformats.org/drawingml/2006/main"/>
           <a:p xmlns:a="http://schemas.openxmlformats.org/drawingml/2006/main">
             <a:pPr>
+              <a:buNone/>
               <a:defRPr sz="2025" b="0">
                 <a:solidFill>
                   <a:srgbClr val="526872"/>
@@ -11966,6 +12091,7 @@
           <a:lstStyle xmlns:a="http://schemas.openxmlformats.org/drawingml/2006/main"/>
           <a:p xmlns:a="http://schemas.openxmlformats.org/drawingml/2006/main">
             <a:pPr>
+              <a:buNone/>
               <a:defRPr sz="2025" b="1">
                 <a:solidFill>
                   <a:srgbClr val="006C70"/>
@@ -12023,6 +12149,7 @@
           <a:lstStyle xmlns:a="http://schemas.openxmlformats.org/drawingml/2006/main"/>
           <a:p xmlns:a="http://schemas.openxmlformats.org/drawingml/2006/main">
             <a:pPr>
+              <a:buNone/>
               <a:defRPr sz="2100" b="0">
                 <a:solidFill>
                   <a:srgbClr val="153040"/>
@@ -12110,6 +12237,7 @@
           <a:lstStyle xmlns:a="http://schemas.openxmlformats.org/drawingml/2006/main"/>
           <a:p xmlns:a="http://schemas.openxmlformats.org/drawingml/2006/main">
             <a:pPr>
+              <a:buNone/>
               <a:defRPr sz="2025" b="1">
                 <a:solidFill>
                   <a:srgbClr val="006C70"/>
@@ -12167,6 +12295,7 @@
           <a:lstStyle xmlns:a="http://schemas.openxmlformats.org/drawingml/2006/main"/>
           <a:p xmlns:a="http://schemas.openxmlformats.org/drawingml/2006/main">
             <a:pPr>
+              <a:buNone/>
               <a:defRPr sz="2100" b="0">
                 <a:solidFill>
                   <a:srgbClr val="153040"/>
@@ -12254,6 +12383,7 @@
           <a:lstStyle xmlns:a="http://schemas.openxmlformats.org/drawingml/2006/main"/>
           <a:p xmlns:a="http://schemas.openxmlformats.org/drawingml/2006/main">
             <a:pPr>
+              <a:buNone/>
               <a:defRPr sz="2025" b="1">
                 <a:solidFill>
                   <a:srgbClr val="006C70"/>
@@ -12311,6 +12441,7 @@
           <a:lstStyle xmlns:a="http://schemas.openxmlformats.org/drawingml/2006/main"/>
           <a:p xmlns:a="http://schemas.openxmlformats.org/drawingml/2006/main">
             <a:pPr>
+              <a:buNone/>
               <a:defRPr sz="2100" b="0">
                 <a:solidFill>
                   <a:srgbClr val="153040"/>
@@ -12398,6 +12529,7 @@
           <a:lstStyle xmlns:a="http://schemas.openxmlformats.org/drawingml/2006/main"/>
           <a:p xmlns:a="http://schemas.openxmlformats.org/drawingml/2006/main">
             <a:pPr>
+              <a:buNone/>
               <a:defRPr sz="1125" b="0">
                 <a:solidFill>
                   <a:srgbClr val="526872"/>
@@ -12455,6 +12587,7 @@
           <a:lstStyle xmlns:a="http://schemas.openxmlformats.org/drawingml/2006/main"/>
           <a:p xmlns:a="http://schemas.openxmlformats.org/drawingml/2006/main">
             <a:pPr>
+              <a:buNone/>
               <a:defRPr sz="1275" b="0">
                 <a:solidFill>
                   <a:srgbClr val="526872"/>
@@ -12541,6 +12674,7 @@
           <a:lstStyle xmlns:a="http://schemas.openxmlformats.org/drawingml/2006/main"/>
           <a:p xmlns:a="http://schemas.openxmlformats.org/drawingml/2006/main">
             <a:pPr>
+              <a:buNone/>
               <a:defRPr sz="1350" b="1">
                 <a:solidFill>
                   <a:srgbClr val="006C70"/>
@@ -12598,6 +12732,7 @@
           <a:lstStyle xmlns:a="http://schemas.openxmlformats.org/drawingml/2006/main"/>
           <a:p xmlns:a="http://schemas.openxmlformats.org/drawingml/2006/main">
             <a:pPr>
+              <a:buNone/>
               <a:defRPr sz="3225" b="1">
                 <a:solidFill>
                   <a:srgbClr val="153040"/>
@@ -12655,6 +12790,7 @@
           <a:lstStyle xmlns:a="http://schemas.openxmlformats.org/drawingml/2006/main"/>
           <a:p xmlns:a="http://schemas.openxmlformats.org/drawingml/2006/main">
             <a:pPr>
+              <a:buNone/>
               <a:defRPr sz="2025" b="0">
                 <a:solidFill>
                   <a:srgbClr val="526872"/>
@@ -12712,6 +12848,7 @@
           <a:lstStyle xmlns:a="http://schemas.openxmlformats.org/drawingml/2006/main"/>
           <a:p xmlns:a="http://schemas.openxmlformats.org/drawingml/2006/main">
             <a:pPr>
+              <a:buNone/>
               <a:defRPr sz="2025" b="1">
                 <a:solidFill>
                   <a:srgbClr val="006C70"/>
@@ -12769,6 +12906,7 @@
           <a:lstStyle xmlns:a="http://schemas.openxmlformats.org/drawingml/2006/main"/>
           <a:p xmlns:a="http://schemas.openxmlformats.org/drawingml/2006/main">
             <a:pPr>
+              <a:buNone/>
               <a:defRPr sz="2100" b="0">
                 <a:solidFill>
                   <a:srgbClr val="153040"/>
@@ -12856,6 +12994,7 @@
           <a:lstStyle xmlns:a="http://schemas.openxmlformats.org/drawingml/2006/main"/>
           <a:p xmlns:a="http://schemas.openxmlformats.org/drawingml/2006/main">
             <a:pPr>
+              <a:buNone/>
               <a:defRPr sz="2025" b="1">
                 <a:solidFill>
                   <a:srgbClr val="006C70"/>
@@ -12913,6 +13052,7 @@
           <a:lstStyle xmlns:a="http://schemas.openxmlformats.org/drawingml/2006/main"/>
           <a:p xmlns:a="http://schemas.openxmlformats.org/drawingml/2006/main">
             <a:pPr>
+              <a:buNone/>
               <a:defRPr sz="2100" b="0">
                 <a:solidFill>
                   <a:srgbClr val="153040"/>
@@ -13000,6 +13140,7 @@
           <a:lstStyle xmlns:a="http://schemas.openxmlformats.org/drawingml/2006/main"/>
           <a:p xmlns:a="http://schemas.openxmlformats.org/drawingml/2006/main">
             <a:pPr>
+              <a:buNone/>
               <a:defRPr sz="2025" b="1">
                 <a:solidFill>
                   <a:srgbClr val="006C70"/>
@@ -13057,6 +13198,7 @@
           <a:lstStyle xmlns:a="http://schemas.openxmlformats.org/drawingml/2006/main"/>
           <a:p xmlns:a="http://schemas.openxmlformats.org/drawingml/2006/main">
             <a:pPr>
+              <a:buNone/>
               <a:defRPr sz="2100" b="0">
                 <a:solidFill>
                   <a:srgbClr val="153040"/>
@@ -13144,6 +13286,7 @@
           <a:lstStyle xmlns:a="http://schemas.openxmlformats.org/drawingml/2006/main"/>
           <a:p xmlns:a="http://schemas.openxmlformats.org/drawingml/2006/main">
             <a:pPr>
+              <a:buNone/>
               <a:defRPr sz="1125" b="0">
                 <a:solidFill>
                   <a:srgbClr val="526872"/>
@@ -13201,6 +13344,7 @@
           <a:lstStyle xmlns:a="http://schemas.openxmlformats.org/drawingml/2006/main"/>
           <a:p xmlns:a="http://schemas.openxmlformats.org/drawingml/2006/main">
             <a:pPr>
+              <a:buNone/>
               <a:defRPr sz="1275" b="0">
                 <a:solidFill>
                   <a:srgbClr val="526872"/>
@@ -13287,6 +13431,7 @@
           <a:lstStyle xmlns:a="http://schemas.openxmlformats.org/drawingml/2006/main"/>
           <a:p xmlns:a="http://schemas.openxmlformats.org/drawingml/2006/main">
             <a:pPr>
+              <a:buNone/>
               <a:defRPr sz="1350" b="1">
                 <a:solidFill>
                   <a:srgbClr val="006C70"/>
@@ -13344,6 +13489,7 @@
           <a:lstStyle xmlns:a="http://schemas.openxmlformats.org/drawingml/2006/main"/>
           <a:p xmlns:a="http://schemas.openxmlformats.org/drawingml/2006/main">
             <a:pPr>
+              <a:buNone/>
               <a:defRPr sz="3225" b="1">
                 <a:solidFill>
                   <a:srgbClr val="153040"/>
@@ -13401,6 +13547,7 @@
           <a:lstStyle xmlns:a="http://schemas.openxmlformats.org/drawingml/2006/main"/>
           <a:p xmlns:a="http://schemas.openxmlformats.org/drawingml/2006/main">
             <a:pPr>
+              <a:buNone/>
               <a:defRPr sz="2025" b="0">
                 <a:solidFill>
                   <a:srgbClr val="526872"/>
@@ -13458,6 +13605,7 @@
           <a:lstStyle xmlns:a="http://schemas.openxmlformats.org/drawingml/2006/main"/>
           <a:p xmlns:a="http://schemas.openxmlformats.org/drawingml/2006/main">
             <a:pPr>
+              <a:buNone/>
               <a:defRPr sz="2025" b="1">
                 <a:solidFill>
                   <a:srgbClr val="006C70"/>
@@ -13515,6 +13663,7 @@
           <a:lstStyle xmlns:a="http://schemas.openxmlformats.org/drawingml/2006/main"/>
           <a:p xmlns:a="http://schemas.openxmlformats.org/drawingml/2006/main">
             <a:pPr>
+              <a:buNone/>
               <a:defRPr sz="2100" b="0">
                 <a:solidFill>
                   <a:srgbClr val="153040"/>
@@ -13602,6 +13751,7 @@
           <a:lstStyle xmlns:a="http://schemas.openxmlformats.org/drawingml/2006/main"/>
           <a:p xmlns:a="http://schemas.openxmlformats.org/drawingml/2006/main">
             <a:pPr>
+              <a:buNone/>
               <a:defRPr sz="2025" b="1">
                 <a:solidFill>
                   <a:srgbClr val="006C70"/>
@@ -13659,6 +13809,7 @@
           <a:lstStyle xmlns:a="http://schemas.openxmlformats.org/drawingml/2006/main"/>
           <a:p xmlns:a="http://schemas.openxmlformats.org/drawingml/2006/main">
             <a:pPr>
+              <a:buNone/>
               <a:defRPr sz="2100" b="0">
                 <a:solidFill>
                   <a:srgbClr val="153040"/>
@@ -13746,6 +13897,7 @@
           <a:lstStyle xmlns:a="http://schemas.openxmlformats.org/drawingml/2006/main"/>
           <a:p xmlns:a="http://schemas.openxmlformats.org/drawingml/2006/main">
             <a:pPr>
+              <a:buNone/>
               <a:defRPr sz="2025" b="1">
                 <a:solidFill>
                   <a:srgbClr val="006C70"/>
@@ -13803,6 +13955,7 @@
           <a:lstStyle xmlns:a="http://schemas.openxmlformats.org/drawingml/2006/main"/>
           <a:p xmlns:a="http://schemas.openxmlformats.org/drawingml/2006/main">
             <a:pPr>
+              <a:buNone/>
               <a:defRPr sz="2100" b="0">
                 <a:solidFill>
                   <a:srgbClr val="153040"/>
@@ -13890,6 +14043,7 @@
           <a:lstStyle xmlns:a="http://schemas.openxmlformats.org/drawingml/2006/main"/>
           <a:p xmlns:a="http://schemas.openxmlformats.org/drawingml/2006/main">
             <a:pPr>
+              <a:buNone/>
               <a:defRPr sz="1125" b="0">
                 <a:solidFill>
                   <a:srgbClr val="526872"/>
@@ -13947,6 +14101,7 @@
           <a:lstStyle xmlns:a="http://schemas.openxmlformats.org/drawingml/2006/main"/>
           <a:p xmlns:a="http://schemas.openxmlformats.org/drawingml/2006/main">
             <a:pPr>
+              <a:buNone/>
               <a:defRPr sz="1275" b="0">
                 <a:solidFill>
                   <a:srgbClr val="526872"/>
@@ -14033,6 +14188,7 @@
           <a:lstStyle xmlns:a="http://schemas.openxmlformats.org/drawingml/2006/main"/>
           <a:p xmlns:a="http://schemas.openxmlformats.org/drawingml/2006/main">
             <a:pPr>
+              <a:buNone/>
               <a:defRPr sz="1350" b="1">
                 <a:solidFill>
                   <a:srgbClr val="006C70"/>
@@ -14090,6 +14246,7 @@
           <a:lstStyle xmlns:a="http://schemas.openxmlformats.org/drawingml/2006/main"/>
           <a:p xmlns:a="http://schemas.openxmlformats.org/drawingml/2006/main">
             <a:pPr>
+              <a:buNone/>
               <a:defRPr sz="3225" b="1">
                 <a:solidFill>
                   <a:srgbClr val="153040"/>
@@ -14147,6 +14304,7 @@
           <a:lstStyle xmlns:a="http://schemas.openxmlformats.org/drawingml/2006/main"/>
           <a:p xmlns:a="http://schemas.openxmlformats.org/drawingml/2006/main">
             <a:pPr>
+              <a:buNone/>
               <a:defRPr sz="2025" b="0">
                 <a:solidFill>
                   <a:srgbClr val="526872"/>
@@ -14204,6 +14362,7 @@
           <a:lstStyle xmlns:a="http://schemas.openxmlformats.org/drawingml/2006/main"/>
           <a:p xmlns:a="http://schemas.openxmlformats.org/drawingml/2006/main">
             <a:pPr>
+              <a:buNone/>
               <a:defRPr sz="2025" b="1">
                 <a:solidFill>
                   <a:srgbClr val="006C70"/>
@@ -14261,6 +14420,7 @@
           <a:lstStyle xmlns:a="http://schemas.openxmlformats.org/drawingml/2006/main"/>
           <a:p xmlns:a="http://schemas.openxmlformats.org/drawingml/2006/main">
             <a:pPr>
+              <a:buNone/>
               <a:defRPr sz="2100" b="0">
                 <a:solidFill>
                   <a:srgbClr val="153040"/>
@@ -14348,6 +14508,7 @@
           <a:lstStyle xmlns:a="http://schemas.openxmlformats.org/drawingml/2006/main"/>
           <a:p xmlns:a="http://schemas.openxmlformats.org/drawingml/2006/main">
             <a:pPr>
+              <a:buNone/>
               <a:defRPr sz="2025" b="1">
                 <a:solidFill>
                   <a:srgbClr val="006C70"/>
@@ -14405,6 +14566,7 @@
           <a:lstStyle xmlns:a="http://schemas.openxmlformats.org/drawingml/2006/main"/>
           <a:p xmlns:a="http://schemas.openxmlformats.org/drawingml/2006/main">
             <a:pPr>
+              <a:buNone/>
               <a:defRPr sz="2100" b="0">
                 <a:solidFill>
                   <a:srgbClr val="153040"/>
@@ -14492,6 +14654,7 @@
           <a:lstStyle xmlns:a="http://schemas.openxmlformats.org/drawingml/2006/main"/>
           <a:p xmlns:a="http://schemas.openxmlformats.org/drawingml/2006/main">
             <a:pPr>
+              <a:buNone/>
               <a:defRPr sz="2025" b="1">
                 <a:solidFill>
                   <a:srgbClr val="006C70"/>
@@ -14549,6 +14712,7 @@
           <a:lstStyle xmlns:a="http://schemas.openxmlformats.org/drawingml/2006/main"/>
           <a:p xmlns:a="http://schemas.openxmlformats.org/drawingml/2006/main">
             <a:pPr>
+              <a:buNone/>
               <a:defRPr sz="2100" b="0">
                 <a:solidFill>
                   <a:srgbClr val="153040"/>
@@ -14636,6 +14800,7 @@
           <a:lstStyle xmlns:a="http://schemas.openxmlformats.org/drawingml/2006/main"/>
           <a:p xmlns:a="http://schemas.openxmlformats.org/drawingml/2006/main">
             <a:pPr>
+              <a:buNone/>
               <a:defRPr sz="1125" b="0">
                 <a:solidFill>
                   <a:srgbClr val="526872"/>
@@ -14693,6 +14858,7 @@
           <a:lstStyle xmlns:a="http://schemas.openxmlformats.org/drawingml/2006/main"/>
           <a:p xmlns:a="http://schemas.openxmlformats.org/drawingml/2006/main">
             <a:pPr>
+              <a:buNone/>
               <a:defRPr sz="1275" b="0">
                 <a:solidFill>
                   <a:srgbClr val="526872"/>
@@ -14779,6 +14945,7 @@
           <a:lstStyle xmlns:a="http://schemas.openxmlformats.org/drawingml/2006/main"/>
           <a:p xmlns:a="http://schemas.openxmlformats.org/drawingml/2006/main">
             <a:pPr>
+              <a:buNone/>
               <a:defRPr sz="1350" b="1">
                 <a:solidFill>
                   <a:srgbClr val="006C70"/>
@@ -14836,6 +15003,7 @@
           <a:lstStyle xmlns:a="http://schemas.openxmlformats.org/drawingml/2006/main"/>
           <a:p xmlns:a="http://schemas.openxmlformats.org/drawingml/2006/main">
             <a:pPr>
+              <a:buNone/>
               <a:defRPr sz="3225" b="1">
                 <a:solidFill>
                   <a:srgbClr val="153040"/>
@@ -14893,6 +15061,7 @@
           <a:lstStyle xmlns:a="http://schemas.openxmlformats.org/drawingml/2006/main"/>
           <a:p xmlns:a="http://schemas.openxmlformats.org/drawingml/2006/main">
             <a:pPr>
+              <a:buNone/>
               <a:defRPr sz="2025" b="0">
                 <a:solidFill>
                   <a:srgbClr val="526872"/>
@@ -14950,6 +15119,7 @@
           <a:lstStyle xmlns:a="http://schemas.openxmlformats.org/drawingml/2006/main"/>
           <a:p xmlns:a="http://schemas.openxmlformats.org/drawingml/2006/main">
             <a:pPr>
+              <a:buNone/>
               <a:defRPr sz="2025" b="1">
                 <a:solidFill>
                   <a:srgbClr val="006C70"/>
@@ -15007,6 +15177,7 @@
           <a:lstStyle xmlns:a="http://schemas.openxmlformats.org/drawingml/2006/main"/>
           <a:p xmlns:a="http://schemas.openxmlformats.org/drawingml/2006/main">
             <a:pPr>
+              <a:buNone/>
               <a:defRPr sz="2100" b="0">
                 <a:solidFill>
                   <a:srgbClr val="153040"/>
@@ -15094,6 +15265,7 @@
           <a:lstStyle xmlns:a="http://schemas.openxmlformats.org/drawingml/2006/main"/>
           <a:p xmlns:a="http://schemas.openxmlformats.org/drawingml/2006/main">
             <a:pPr>
+              <a:buNone/>
               <a:defRPr sz="2025" b="1">
                 <a:solidFill>
                   <a:srgbClr val="006C70"/>
@@ -15151,6 +15323,7 @@
           <a:lstStyle xmlns:a="http://schemas.openxmlformats.org/drawingml/2006/main"/>
           <a:p xmlns:a="http://schemas.openxmlformats.org/drawingml/2006/main">
             <a:pPr>
+              <a:buNone/>
               <a:defRPr sz="2100" b="0">
                 <a:solidFill>
                   <a:srgbClr val="153040"/>
@@ -15238,6 +15411,7 @@
           <a:lstStyle xmlns:a="http://schemas.openxmlformats.org/drawingml/2006/main"/>
           <a:p xmlns:a="http://schemas.openxmlformats.org/drawingml/2006/main">
             <a:pPr>
+              <a:buNone/>
               <a:defRPr sz="2025" b="1">
                 <a:solidFill>
                   <a:srgbClr val="006C70"/>
@@ -15295,6 +15469,7 @@
           <a:lstStyle xmlns:a="http://schemas.openxmlformats.org/drawingml/2006/main"/>
           <a:p xmlns:a="http://schemas.openxmlformats.org/drawingml/2006/main">
             <a:pPr>
+              <a:buNone/>
               <a:defRPr sz="2100" b="0">
                 <a:solidFill>
                   <a:srgbClr val="153040"/>
@@ -15382,6 +15557,7 @@
           <a:lstStyle xmlns:a="http://schemas.openxmlformats.org/drawingml/2006/main"/>
           <a:p xmlns:a="http://schemas.openxmlformats.org/drawingml/2006/main">
             <a:pPr>
+              <a:buNone/>
               <a:defRPr sz="1125" b="0">
                 <a:solidFill>
                   <a:srgbClr val="526872"/>
@@ -15439,6 +15615,7 @@
           <a:lstStyle xmlns:a="http://schemas.openxmlformats.org/drawingml/2006/main"/>
           <a:p xmlns:a="http://schemas.openxmlformats.org/drawingml/2006/main">
             <a:pPr>
+              <a:buNone/>
               <a:defRPr sz="1275" b="0">
                 <a:solidFill>
                   <a:srgbClr val="526872"/>
@@ -15525,6 +15702,7 @@
           <a:lstStyle xmlns:a="http://schemas.openxmlformats.org/drawingml/2006/main"/>
           <a:p xmlns:a="http://schemas.openxmlformats.org/drawingml/2006/main">
             <a:pPr>
+              <a:buNone/>
               <a:defRPr sz="1350" b="1">
                 <a:solidFill>
                   <a:srgbClr val="006C70"/>
@@ -15582,6 +15760,7 @@
           <a:lstStyle xmlns:a="http://schemas.openxmlformats.org/drawingml/2006/main"/>
           <a:p xmlns:a="http://schemas.openxmlformats.org/drawingml/2006/main">
             <a:pPr>
+              <a:buNone/>
               <a:defRPr sz="3225" b="1">
                 <a:solidFill>
                   <a:srgbClr val="153040"/>
@@ -15639,6 +15818,7 @@
           <a:lstStyle xmlns:a="http://schemas.openxmlformats.org/drawingml/2006/main"/>
           <a:p xmlns:a="http://schemas.openxmlformats.org/drawingml/2006/main">
             <a:pPr>
+              <a:buNone/>
               <a:defRPr sz="2025" b="0">
                 <a:solidFill>
                   <a:srgbClr val="526872"/>
@@ -15700,6 +15880,7 @@
           <a:lstStyle xmlns:a="http://schemas.openxmlformats.org/drawingml/2006/main"/>
           <a:p xmlns:a="http://schemas.openxmlformats.org/drawingml/2006/main">
             <a:pPr algn="ctr">
+              <a:buNone/>
               <a:defRPr sz="1875" b="1">
                 <a:solidFill>
                   <a:srgbClr val="006C70"/>
@@ -15757,6 +15938,7 @@
           <a:lstStyle xmlns:a="http://schemas.openxmlformats.org/drawingml/2006/main"/>
           <a:p xmlns:a="http://schemas.openxmlformats.org/drawingml/2006/main">
             <a:pPr>
+              <a:buNone/>
               <a:defRPr sz="2100" b="0">
                 <a:solidFill>
                   <a:srgbClr val="153040"/>
@@ -15818,6 +16000,7 @@
           <a:lstStyle xmlns:a="http://schemas.openxmlformats.org/drawingml/2006/main"/>
           <a:p xmlns:a="http://schemas.openxmlformats.org/drawingml/2006/main">
             <a:pPr algn="ctr">
+              <a:buNone/>
               <a:defRPr sz="1875" b="1">
                 <a:solidFill>
                   <a:srgbClr val="006C70"/>
@@ -15843,7 +16026,7 @@
       </p:sp>
       <p:cxnSp>
         <p:nvCxnSpPr>
-          <p:cNvPr id="24" name=""/>
+          <p:cNvPr id="37" name=""/>
           <p:cNvCxnSpPr>
             <a:stCxn xmlns:a="http://schemas.openxmlformats.org/drawingml/2006/main" id="4" idx="2"/>
             <a:endCxn xmlns:a="http://schemas.openxmlformats.org/drawingml/2006/main" id="6" idx="0"/>
@@ -15900,6 +16083,7 @@
           <a:lstStyle xmlns:a="http://schemas.openxmlformats.org/drawingml/2006/main"/>
           <a:p xmlns:a="http://schemas.openxmlformats.org/drawingml/2006/main">
             <a:pPr>
+              <a:buNone/>
               <a:defRPr sz="2100" b="0">
                 <a:solidFill>
                   <a:srgbClr val="153040"/>
@@ -15961,6 +16145,7 @@
           <a:lstStyle xmlns:a="http://schemas.openxmlformats.org/drawingml/2006/main"/>
           <a:p xmlns:a="http://schemas.openxmlformats.org/drawingml/2006/main">
             <a:pPr algn="ctr">
+              <a:buNone/>
               <a:defRPr sz="1875" b="1">
                 <a:solidFill>
                   <a:srgbClr val="006C70"/>
@@ -15986,7 +16171,7 @@
       </p:sp>
       <p:cxnSp>
         <p:nvCxnSpPr>
-          <p:cNvPr id="27" name=""/>
+          <p:cNvPr id="40" name=""/>
           <p:cNvCxnSpPr>
             <a:stCxn xmlns:a="http://schemas.openxmlformats.org/drawingml/2006/main" id="6" idx="2"/>
             <a:endCxn xmlns:a="http://schemas.openxmlformats.org/drawingml/2006/main" id="9" idx="0"/>
@@ -16043,6 +16228,7 @@
           <a:lstStyle xmlns:a="http://schemas.openxmlformats.org/drawingml/2006/main"/>
           <a:p xmlns:a="http://schemas.openxmlformats.org/drawingml/2006/main">
             <a:pPr>
+              <a:buNone/>
               <a:defRPr sz="2100" b="0">
                 <a:solidFill>
                   <a:srgbClr val="153040"/>
@@ -16104,6 +16290,7 @@
           <a:lstStyle xmlns:a="http://schemas.openxmlformats.org/drawingml/2006/main"/>
           <a:p xmlns:a="http://schemas.openxmlformats.org/drawingml/2006/main">
             <a:pPr algn="ctr">
+              <a:buNone/>
               <a:defRPr sz="1875" b="1">
                 <a:solidFill>
                   <a:srgbClr val="006C70"/>
@@ -16129,7 +16316,7 @@
       </p:sp>
       <p:cxnSp>
         <p:nvCxnSpPr>
-          <p:cNvPr id="30" name=""/>
+          <p:cNvPr id="43" name=""/>
           <p:cNvCxnSpPr>
             <a:stCxn xmlns:a="http://schemas.openxmlformats.org/drawingml/2006/main" id="9" idx="2"/>
             <a:endCxn xmlns:a="http://schemas.openxmlformats.org/drawingml/2006/main" id="12" idx="0"/>
@@ -16186,6 +16373,7 @@
           <a:lstStyle xmlns:a="http://schemas.openxmlformats.org/drawingml/2006/main"/>
           <a:p xmlns:a="http://schemas.openxmlformats.org/drawingml/2006/main">
             <a:pPr>
+              <a:buNone/>
               <a:defRPr sz="2100" b="0">
                 <a:solidFill>
                   <a:srgbClr val="153040"/>
@@ -16273,6 +16461,7 @@
           <a:lstStyle xmlns:a="http://schemas.openxmlformats.org/drawingml/2006/main"/>
           <a:p xmlns:a="http://schemas.openxmlformats.org/drawingml/2006/main">
             <a:pPr>
+              <a:buNone/>
               <a:defRPr sz="1125" b="0">
                 <a:solidFill>
                   <a:srgbClr val="526872"/>
@@ -16330,6 +16519,7 @@
           <a:lstStyle xmlns:a="http://schemas.openxmlformats.org/drawingml/2006/main"/>
           <a:p xmlns:a="http://schemas.openxmlformats.org/drawingml/2006/main">
             <a:pPr>
+              <a:buNone/>
               <a:defRPr sz="1275" b="0">
                 <a:solidFill>
                   <a:srgbClr val="526872"/>
@@ -16416,6 +16606,7 @@
           <a:lstStyle xmlns:a="http://schemas.openxmlformats.org/drawingml/2006/main"/>
           <a:p xmlns:a="http://schemas.openxmlformats.org/drawingml/2006/main">
             <a:pPr>
+              <a:buNone/>
               <a:defRPr sz="1350" b="1">
                 <a:solidFill>
                   <a:srgbClr val="006C70"/>
@@ -16473,6 +16664,7 @@
           <a:lstStyle xmlns:a="http://schemas.openxmlformats.org/drawingml/2006/main"/>
           <a:p xmlns:a="http://schemas.openxmlformats.org/drawingml/2006/main">
             <a:pPr>
+              <a:buNone/>
               <a:defRPr sz="3225" b="1">
                 <a:solidFill>
                   <a:srgbClr val="153040"/>
@@ -16530,6 +16722,7 @@
           <a:lstStyle xmlns:a="http://schemas.openxmlformats.org/drawingml/2006/main"/>
           <a:p xmlns:a="http://schemas.openxmlformats.org/drawingml/2006/main">
             <a:pPr>
+              <a:buNone/>
               <a:defRPr sz="2025" b="0">
                 <a:solidFill>
                   <a:srgbClr val="526872"/>
@@ -16587,6 +16780,7 @@
           <a:lstStyle xmlns:a="http://schemas.openxmlformats.org/drawingml/2006/main"/>
           <a:p xmlns:a="http://schemas.openxmlformats.org/drawingml/2006/main">
             <a:pPr>
+              <a:buNone/>
               <a:defRPr sz="2025" b="1">
                 <a:solidFill>
                   <a:srgbClr val="006C70"/>
@@ -16644,6 +16838,7 @@
           <a:lstStyle xmlns:a="http://schemas.openxmlformats.org/drawingml/2006/main"/>
           <a:p xmlns:a="http://schemas.openxmlformats.org/drawingml/2006/main">
             <a:pPr>
+              <a:buNone/>
               <a:defRPr sz="2100" b="0">
                 <a:solidFill>
                   <a:srgbClr val="153040"/>
@@ -16731,6 +16926,7 @@
           <a:lstStyle xmlns:a="http://schemas.openxmlformats.org/drawingml/2006/main"/>
           <a:p xmlns:a="http://schemas.openxmlformats.org/drawingml/2006/main">
             <a:pPr>
+              <a:buNone/>
               <a:defRPr sz="2025" b="1">
                 <a:solidFill>
                   <a:srgbClr val="006C70"/>
@@ -16788,6 +16984,7 @@
           <a:lstStyle xmlns:a="http://schemas.openxmlformats.org/drawingml/2006/main"/>
           <a:p xmlns:a="http://schemas.openxmlformats.org/drawingml/2006/main">
             <a:pPr>
+              <a:buNone/>
               <a:defRPr sz="2100" b="0">
                 <a:solidFill>
                   <a:srgbClr val="153040"/>
@@ -16875,6 +17072,7 @@
           <a:lstStyle xmlns:a="http://schemas.openxmlformats.org/drawingml/2006/main"/>
           <a:p xmlns:a="http://schemas.openxmlformats.org/drawingml/2006/main">
             <a:pPr>
+              <a:buNone/>
               <a:defRPr sz="2025" b="1">
                 <a:solidFill>
                   <a:srgbClr val="006C70"/>
@@ -16932,6 +17130,7 @@
           <a:lstStyle xmlns:a="http://schemas.openxmlformats.org/drawingml/2006/main"/>
           <a:p xmlns:a="http://schemas.openxmlformats.org/drawingml/2006/main">
             <a:pPr>
+              <a:buNone/>
               <a:defRPr sz="2100" b="0">
                 <a:solidFill>
                   <a:srgbClr val="153040"/>
@@ -17019,6 +17218,7 @@
           <a:lstStyle xmlns:a="http://schemas.openxmlformats.org/drawingml/2006/main"/>
           <a:p xmlns:a="http://schemas.openxmlformats.org/drawingml/2006/main">
             <a:pPr>
+              <a:buNone/>
               <a:defRPr sz="1125" b="0">
                 <a:solidFill>
                   <a:srgbClr val="526872"/>
@@ -17076,6 +17276,7 @@
           <a:lstStyle xmlns:a="http://schemas.openxmlformats.org/drawingml/2006/main"/>
           <a:p xmlns:a="http://schemas.openxmlformats.org/drawingml/2006/main">
             <a:pPr>
+              <a:buNone/>
               <a:defRPr sz="1275" b="0">
                 <a:solidFill>
                   <a:srgbClr val="526872"/>
@@ -17162,6 +17363,7 @@
           <a:lstStyle xmlns:a="http://schemas.openxmlformats.org/drawingml/2006/main"/>
           <a:p xmlns:a="http://schemas.openxmlformats.org/drawingml/2006/main">
             <a:pPr>
+              <a:buNone/>
               <a:defRPr sz="1350" b="1">
                 <a:solidFill>
                   <a:srgbClr val="006C70"/>
@@ -17219,6 +17421,7 @@
           <a:lstStyle xmlns:a="http://schemas.openxmlformats.org/drawingml/2006/main"/>
           <a:p xmlns:a="http://schemas.openxmlformats.org/drawingml/2006/main">
             <a:pPr>
+              <a:buNone/>
               <a:defRPr sz="3225" b="1">
                 <a:solidFill>
                   <a:srgbClr val="153040"/>
@@ -17276,6 +17479,7 @@
           <a:lstStyle xmlns:a="http://schemas.openxmlformats.org/drawingml/2006/main"/>
           <a:p xmlns:a="http://schemas.openxmlformats.org/drawingml/2006/main">
             <a:pPr>
+              <a:buNone/>
               <a:defRPr sz="2025" b="0">
                 <a:solidFill>
                   <a:srgbClr val="526872"/>
@@ -17333,6 +17537,7 @@
           <a:lstStyle xmlns:a="http://schemas.openxmlformats.org/drawingml/2006/main"/>
           <a:p xmlns:a="http://schemas.openxmlformats.org/drawingml/2006/main">
             <a:pPr>
+              <a:buNone/>
               <a:defRPr sz="2025" b="1">
                 <a:solidFill>
                   <a:srgbClr val="006C70"/>
@@ -17390,6 +17595,7 @@
           <a:lstStyle xmlns:a="http://schemas.openxmlformats.org/drawingml/2006/main"/>
           <a:p xmlns:a="http://schemas.openxmlformats.org/drawingml/2006/main">
             <a:pPr>
+              <a:buNone/>
               <a:defRPr sz="2100" b="0">
                 <a:solidFill>
                   <a:srgbClr val="153040"/>
@@ -17477,6 +17683,7 @@
           <a:lstStyle xmlns:a="http://schemas.openxmlformats.org/drawingml/2006/main"/>
           <a:p xmlns:a="http://schemas.openxmlformats.org/drawingml/2006/main">
             <a:pPr>
+              <a:buNone/>
               <a:defRPr sz="2025" b="1">
                 <a:solidFill>
                   <a:srgbClr val="006C70"/>
@@ -17534,6 +17741,7 @@
           <a:lstStyle xmlns:a="http://schemas.openxmlformats.org/drawingml/2006/main"/>
           <a:p xmlns:a="http://schemas.openxmlformats.org/drawingml/2006/main">
             <a:pPr>
+              <a:buNone/>
               <a:defRPr sz="2100" b="0">
                 <a:solidFill>
                   <a:srgbClr val="153040"/>
@@ -17621,6 +17829,7 @@
           <a:lstStyle xmlns:a="http://schemas.openxmlformats.org/drawingml/2006/main"/>
           <a:p xmlns:a="http://schemas.openxmlformats.org/drawingml/2006/main">
             <a:pPr>
+              <a:buNone/>
               <a:defRPr sz="2025" b="1">
                 <a:solidFill>
                   <a:srgbClr val="006C70"/>
@@ -17678,6 +17887,7 @@
           <a:lstStyle xmlns:a="http://schemas.openxmlformats.org/drawingml/2006/main"/>
           <a:p xmlns:a="http://schemas.openxmlformats.org/drawingml/2006/main">
             <a:pPr>
+              <a:buNone/>
               <a:defRPr sz="2100" b="0">
                 <a:solidFill>
                   <a:srgbClr val="153040"/>
@@ -17765,6 +17975,7 @@
           <a:lstStyle xmlns:a="http://schemas.openxmlformats.org/drawingml/2006/main"/>
           <a:p xmlns:a="http://schemas.openxmlformats.org/drawingml/2006/main">
             <a:pPr>
+              <a:buNone/>
               <a:defRPr sz="1125" b="0">
                 <a:solidFill>
                   <a:srgbClr val="526872"/>
@@ -17822,6 +18033,7 @@
           <a:lstStyle xmlns:a="http://schemas.openxmlformats.org/drawingml/2006/main"/>
           <a:p xmlns:a="http://schemas.openxmlformats.org/drawingml/2006/main">
             <a:pPr>
+              <a:buNone/>
               <a:defRPr sz="1275" b="0">
                 <a:solidFill>
                   <a:srgbClr val="526872"/>
@@ -17908,6 +18120,7 @@
           <a:lstStyle xmlns:a="http://schemas.openxmlformats.org/drawingml/2006/main"/>
           <a:p xmlns:a="http://schemas.openxmlformats.org/drawingml/2006/main">
             <a:pPr>
+              <a:buNone/>
               <a:defRPr sz="1350" b="1">
                 <a:solidFill>
                   <a:srgbClr val="006C70"/>
@@ -17965,6 +18178,7 @@
           <a:lstStyle xmlns:a="http://schemas.openxmlformats.org/drawingml/2006/main"/>
           <a:p xmlns:a="http://schemas.openxmlformats.org/drawingml/2006/main">
             <a:pPr>
+              <a:buNone/>
               <a:defRPr sz="3225" b="1">
                 <a:solidFill>
                   <a:srgbClr val="153040"/>
@@ -18022,6 +18236,7 @@
           <a:lstStyle xmlns:a="http://schemas.openxmlformats.org/drawingml/2006/main"/>
           <a:p xmlns:a="http://schemas.openxmlformats.org/drawingml/2006/main">
             <a:pPr>
+              <a:buNone/>
               <a:defRPr sz="2025" b="0">
                 <a:solidFill>
                   <a:srgbClr val="526872"/>
@@ -18079,6 +18294,7 @@
           <a:lstStyle xmlns:a="http://schemas.openxmlformats.org/drawingml/2006/main"/>
           <a:p xmlns:a="http://schemas.openxmlformats.org/drawingml/2006/main">
             <a:pPr>
+              <a:buNone/>
               <a:defRPr sz="2025" b="1">
                 <a:solidFill>
                   <a:srgbClr val="006C70"/>
@@ -18136,6 +18352,7 @@
           <a:lstStyle xmlns:a="http://schemas.openxmlformats.org/drawingml/2006/main"/>
           <a:p xmlns:a="http://schemas.openxmlformats.org/drawingml/2006/main">
             <a:pPr>
+              <a:buNone/>
               <a:defRPr sz="2100" b="0">
                 <a:solidFill>
                   <a:srgbClr val="153040"/>
@@ -18223,6 +18440,7 @@
           <a:lstStyle xmlns:a="http://schemas.openxmlformats.org/drawingml/2006/main"/>
           <a:p xmlns:a="http://schemas.openxmlformats.org/drawingml/2006/main">
             <a:pPr>
+              <a:buNone/>
               <a:defRPr sz="2025" b="1">
                 <a:solidFill>
                   <a:srgbClr val="006C70"/>
@@ -18280,6 +18498,7 @@
           <a:lstStyle xmlns:a="http://schemas.openxmlformats.org/drawingml/2006/main"/>
           <a:p xmlns:a="http://schemas.openxmlformats.org/drawingml/2006/main">
             <a:pPr>
+              <a:buNone/>
               <a:defRPr sz="2100" b="0">
                 <a:solidFill>
                   <a:srgbClr val="153040"/>
@@ -18367,6 +18586,7 @@
           <a:lstStyle xmlns:a="http://schemas.openxmlformats.org/drawingml/2006/main"/>
           <a:p xmlns:a="http://schemas.openxmlformats.org/drawingml/2006/main">
             <a:pPr>
+              <a:buNone/>
               <a:defRPr sz="2025" b="1">
                 <a:solidFill>
                   <a:srgbClr val="006C70"/>
@@ -18424,6 +18644,7 @@
           <a:lstStyle xmlns:a="http://schemas.openxmlformats.org/drawingml/2006/main"/>
           <a:p xmlns:a="http://schemas.openxmlformats.org/drawingml/2006/main">
             <a:pPr>
+              <a:buNone/>
               <a:defRPr sz="2100" b="0">
                 <a:solidFill>
                   <a:srgbClr val="153040"/>
@@ -18511,6 +18732,7 @@
           <a:lstStyle xmlns:a="http://schemas.openxmlformats.org/drawingml/2006/main"/>
           <a:p xmlns:a="http://schemas.openxmlformats.org/drawingml/2006/main">
             <a:pPr>
+              <a:buNone/>
               <a:defRPr sz="1125" b="0">
                 <a:solidFill>
                   <a:srgbClr val="526872"/>
@@ -18568,6 +18790,7 @@
           <a:lstStyle xmlns:a="http://schemas.openxmlformats.org/drawingml/2006/main"/>
           <a:p xmlns:a="http://schemas.openxmlformats.org/drawingml/2006/main">
             <a:pPr>
+              <a:buNone/>
               <a:defRPr sz="1275" b="0">
                 <a:solidFill>
                   <a:srgbClr val="526872"/>
@@ -18654,6 +18877,7 @@
           <a:lstStyle xmlns:a="http://schemas.openxmlformats.org/drawingml/2006/main"/>
           <a:p xmlns:a="http://schemas.openxmlformats.org/drawingml/2006/main">
             <a:pPr>
+              <a:buNone/>
               <a:defRPr sz="1350" b="1">
                 <a:solidFill>
                   <a:srgbClr val="006C70"/>
@@ -18711,6 +18935,7 @@
           <a:lstStyle xmlns:a="http://schemas.openxmlformats.org/drawingml/2006/main"/>
           <a:p xmlns:a="http://schemas.openxmlformats.org/drawingml/2006/main">
             <a:pPr>
+              <a:buNone/>
               <a:defRPr sz="3225" b="1">
                 <a:solidFill>
                   <a:srgbClr val="153040"/>
@@ -18768,6 +18993,7 @@
           <a:lstStyle xmlns:a="http://schemas.openxmlformats.org/drawingml/2006/main"/>
           <a:p xmlns:a="http://schemas.openxmlformats.org/drawingml/2006/main">
             <a:pPr>
+              <a:buNone/>
               <a:defRPr sz="2025" b="0">
                 <a:solidFill>
                   <a:srgbClr val="526872"/>
@@ -18825,6 +19051,7 @@
           <a:lstStyle xmlns:a="http://schemas.openxmlformats.org/drawingml/2006/main"/>
           <a:p xmlns:a="http://schemas.openxmlformats.org/drawingml/2006/main">
             <a:pPr>
+              <a:buNone/>
               <a:defRPr sz="1275" b="1">
                 <a:solidFill>
                   <a:srgbClr val="006C70"/>
@@ -18882,6 +19109,7 @@
           <a:lstStyle xmlns:a="http://schemas.openxmlformats.org/drawingml/2006/main"/>
           <a:p xmlns:a="http://schemas.openxmlformats.org/drawingml/2006/main">
             <a:pPr>
+              <a:buNone/>
               <a:defRPr sz="1290" b="0">
                 <a:solidFill>
                   <a:srgbClr val="153040"/>
@@ -18939,6 +19167,7 @@
           <a:lstStyle xmlns:a="http://schemas.openxmlformats.org/drawingml/2006/main"/>
           <a:p xmlns:a="http://schemas.openxmlformats.org/drawingml/2006/main">
             <a:pPr>
+              <a:buNone/>
               <a:defRPr sz="1275" b="1">
                 <a:solidFill>
                   <a:srgbClr val="006C70"/>
@@ -18996,6 +19225,7 @@
           <a:lstStyle xmlns:a="http://schemas.openxmlformats.org/drawingml/2006/main"/>
           <a:p xmlns:a="http://schemas.openxmlformats.org/drawingml/2006/main">
             <a:pPr>
+              <a:buNone/>
               <a:defRPr sz="1290" b="0">
                 <a:solidFill>
                   <a:srgbClr val="153040"/>
@@ -19053,6 +19283,7 @@
           <a:lstStyle xmlns:a="http://schemas.openxmlformats.org/drawingml/2006/main"/>
           <a:p xmlns:a="http://schemas.openxmlformats.org/drawingml/2006/main">
             <a:pPr>
+              <a:buNone/>
               <a:defRPr sz="1275" b="1">
                 <a:solidFill>
                   <a:srgbClr val="006C70"/>
@@ -19110,6 +19341,7 @@
           <a:lstStyle xmlns:a="http://schemas.openxmlformats.org/drawingml/2006/main"/>
           <a:p xmlns:a="http://schemas.openxmlformats.org/drawingml/2006/main">
             <a:pPr>
+              <a:buNone/>
               <a:defRPr sz="1290" b="0">
                 <a:solidFill>
                   <a:srgbClr val="153040"/>
@@ -19167,6 +19399,7 @@
           <a:lstStyle xmlns:a="http://schemas.openxmlformats.org/drawingml/2006/main"/>
           <a:p xmlns:a="http://schemas.openxmlformats.org/drawingml/2006/main">
             <a:pPr>
+              <a:buNone/>
               <a:defRPr sz="1275" b="1">
                 <a:solidFill>
                   <a:srgbClr val="006C70"/>
@@ -19224,6 +19457,7 @@
           <a:lstStyle xmlns:a="http://schemas.openxmlformats.org/drawingml/2006/main"/>
           <a:p xmlns:a="http://schemas.openxmlformats.org/drawingml/2006/main">
             <a:pPr>
+              <a:buNone/>
               <a:defRPr sz="1290" b="0">
                 <a:solidFill>
                   <a:srgbClr val="153040"/>
@@ -19281,6 +19515,7 @@
           <a:lstStyle xmlns:a="http://schemas.openxmlformats.org/drawingml/2006/main"/>
           <a:p xmlns:a="http://schemas.openxmlformats.org/drawingml/2006/main">
             <a:pPr>
+              <a:buNone/>
               <a:defRPr sz="1275" b="1">
                 <a:solidFill>
                   <a:srgbClr val="006C70"/>
@@ -19338,6 +19573,7 @@
           <a:lstStyle xmlns:a="http://schemas.openxmlformats.org/drawingml/2006/main"/>
           <a:p xmlns:a="http://schemas.openxmlformats.org/drawingml/2006/main">
             <a:pPr>
+              <a:buNone/>
               <a:defRPr sz="1290" b="0">
                 <a:solidFill>
                   <a:srgbClr val="153040"/>
@@ -19395,6 +19631,7 @@
           <a:lstStyle xmlns:a="http://schemas.openxmlformats.org/drawingml/2006/main"/>
           <a:p xmlns:a="http://schemas.openxmlformats.org/drawingml/2006/main">
             <a:pPr>
+              <a:buNone/>
               <a:defRPr sz="1275" b="1">
                 <a:solidFill>
                   <a:srgbClr val="006C70"/>
@@ -19452,6 +19689,7 @@
           <a:lstStyle xmlns:a="http://schemas.openxmlformats.org/drawingml/2006/main"/>
           <a:p xmlns:a="http://schemas.openxmlformats.org/drawingml/2006/main">
             <a:pPr>
+              <a:buNone/>
               <a:defRPr sz="1290" b="0">
                 <a:solidFill>
                   <a:srgbClr val="153040"/>
@@ -19509,6 +19747,7 @@
           <a:lstStyle xmlns:a="http://schemas.openxmlformats.org/drawingml/2006/main"/>
           <a:p xmlns:a="http://schemas.openxmlformats.org/drawingml/2006/main">
             <a:pPr>
+              <a:buNone/>
               <a:defRPr sz="1275" b="1">
                 <a:solidFill>
                   <a:srgbClr val="006C70"/>
@@ -19566,6 +19805,7 @@
           <a:lstStyle xmlns:a="http://schemas.openxmlformats.org/drawingml/2006/main"/>
           <a:p xmlns:a="http://schemas.openxmlformats.org/drawingml/2006/main">
             <a:pPr>
+              <a:buNone/>
               <a:defRPr sz="1290" b="0">
                 <a:solidFill>
                   <a:srgbClr val="153040"/>
@@ -19623,6 +19863,7 @@
           <a:lstStyle xmlns:a="http://schemas.openxmlformats.org/drawingml/2006/main"/>
           <a:p xmlns:a="http://schemas.openxmlformats.org/drawingml/2006/main">
             <a:pPr>
+              <a:buNone/>
               <a:defRPr sz="1275" b="1">
                 <a:solidFill>
                   <a:srgbClr val="006C70"/>
@@ -19680,6 +19921,7 @@
           <a:lstStyle xmlns:a="http://schemas.openxmlformats.org/drawingml/2006/main"/>
           <a:p xmlns:a="http://schemas.openxmlformats.org/drawingml/2006/main">
             <a:pPr>
+              <a:buNone/>
               <a:defRPr sz="1290" b="0">
                 <a:solidFill>
                   <a:srgbClr val="153040"/>
@@ -19767,6 +20009,7 @@
           <a:lstStyle xmlns:a="http://schemas.openxmlformats.org/drawingml/2006/main"/>
           <a:p xmlns:a="http://schemas.openxmlformats.org/drawingml/2006/main">
             <a:pPr>
+              <a:buNone/>
               <a:defRPr sz="1125" b="0">
                 <a:solidFill>
                   <a:srgbClr val="526872"/>
@@ -19824,6 +20067,7 @@
           <a:lstStyle xmlns:a="http://schemas.openxmlformats.org/drawingml/2006/main"/>
           <a:p xmlns:a="http://schemas.openxmlformats.org/drawingml/2006/main">
             <a:pPr>
+              <a:buNone/>
               <a:defRPr sz="1275" b="0">
                 <a:solidFill>
                   <a:srgbClr val="526872"/>
@@ -19910,6 +20154,7 @@
           <a:lstStyle xmlns:a="http://schemas.openxmlformats.org/drawingml/2006/main"/>
           <a:p xmlns:a="http://schemas.openxmlformats.org/drawingml/2006/main">
             <a:pPr>
+              <a:buNone/>
               <a:defRPr sz="1350" b="1">
                 <a:solidFill>
                   <a:srgbClr val="006C70"/>
@@ -19967,6 +20212,7 @@
           <a:lstStyle xmlns:a="http://schemas.openxmlformats.org/drawingml/2006/main"/>
           <a:p xmlns:a="http://schemas.openxmlformats.org/drawingml/2006/main">
             <a:pPr>
+              <a:buNone/>
               <a:defRPr sz="3225" b="1">
                 <a:solidFill>
                   <a:srgbClr val="153040"/>
@@ -20024,6 +20270,7 @@
           <a:lstStyle xmlns:a="http://schemas.openxmlformats.org/drawingml/2006/main"/>
           <a:p xmlns:a="http://schemas.openxmlformats.org/drawingml/2006/main">
             <a:pPr>
+              <a:buNone/>
               <a:defRPr sz="2025" b="0">
                 <a:solidFill>
                   <a:srgbClr val="526872"/>
@@ -20081,6 +20328,7 @@
           <a:lstStyle xmlns:a="http://schemas.openxmlformats.org/drawingml/2006/main"/>
           <a:p xmlns:a="http://schemas.openxmlformats.org/drawingml/2006/main">
             <a:pPr>
+              <a:buNone/>
               <a:defRPr sz="1275" b="1">
                 <a:solidFill>
                   <a:srgbClr val="006C70"/>
@@ -20138,6 +20386,7 @@
           <a:lstStyle xmlns:a="http://schemas.openxmlformats.org/drawingml/2006/main"/>
           <a:p xmlns:a="http://schemas.openxmlformats.org/drawingml/2006/main">
             <a:pPr>
+              <a:buNone/>
               <a:defRPr sz="1290" b="0">
                 <a:solidFill>
                   <a:srgbClr val="153040"/>
@@ -20195,6 +20444,7 @@
           <a:lstStyle xmlns:a="http://schemas.openxmlformats.org/drawingml/2006/main"/>
           <a:p xmlns:a="http://schemas.openxmlformats.org/drawingml/2006/main">
             <a:pPr>
+              <a:buNone/>
               <a:defRPr sz="1275" b="1">
                 <a:solidFill>
                   <a:srgbClr val="006C70"/>
@@ -20252,6 +20502,7 @@
           <a:lstStyle xmlns:a="http://schemas.openxmlformats.org/drawingml/2006/main"/>
           <a:p xmlns:a="http://schemas.openxmlformats.org/drawingml/2006/main">
             <a:pPr>
+              <a:buNone/>
               <a:defRPr sz="1290" b="0">
                 <a:solidFill>
                   <a:srgbClr val="153040"/>
@@ -20309,6 +20560,7 @@
           <a:lstStyle xmlns:a="http://schemas.openxmlformats.org/drawingml/2006/main"/>
           <a:p xmlns:a="http://schemas.openxmlformats.org/drawingml/2006/main">
             <a:pPr>
+              <a:buNone/>
               <a:defRPr sz="1275" b="1">
                 <a:solidFill>
                   <a:srgbClr val="006C70"/>
@@ -20366,6 +20618,7 @@
           <a:lstStyle xmlns:a="http://schemas.openxmlformats.org/drawingml/2006/main"/>
           <a:p xmlns:a="http://schemas.openxmlformats.org/drawingml/2006/main">
             <a:pPr>
+              <a:buNone/>
               <a:defRPr sz="1290" b="0">
                 <a:solidFill>
                   <a:srgbClr val="153040"/>
@@ -20423,6 +20676,7 @@
           <a:lstStyle xmlns:a="http://schemas.openxmlformats.org/drawingml/2006/main"/>
           <a:p xmlns:a="http://schemas.openxmlformats.org/drawingml/2006/main">
             <a:pPr>
+              <a:buNone/>
               <a:defRPr sz="1275" b="1">
                 <a:solidFill>
                   <a:srgbClr val="006C70"/>
@@ -20480,6 +20734,7 @@
           <a:lstStyle xmlns:a="http://schemas.openxmlformats.org/drawingml/2006/main"/>
           <a:p xmlns:a="http://schemas.openxmlformats.org/drawingml/2006/main">
             <a:pPr>
+              <a:buNone/>
               <a:defRPr sz="1290" b="0">
                 <a:solidFill>
                   <a:srgbClr val="153040"/>
@@ -20537,6 +20792,7 @@
           <a:lstStyle xmlns:a="http://schemas.openxmlformats.org/drawingml/2006/main"/>
           <a:p xmlns:a="http://schemas.openxmlformats.org/drawingml/2006/main">
             <a:pPr>
+              <a:buNone/>
               <a:defRPr sz="1275" b="1">
                 <a:solidFill>
                   <a:srgbClr val="006C70"/>
@@ -20594,6 +20850,7 @@
           <a:lstStyle xmlns:a="http://schemas.openxmlformats.org/drawingml/2006/main"/>
           <a:p xmlns:a="http://schemas.openxmlformats.org/drawingml/2006/main">
             <a:pPr>
+              <a:buNone/>
               <a:defRPr sz="1290" b="0">
                 <a:solidFill>
                   <a:srgbClr val="153040"/>
@@ -20651,6 +20908,7 @@
           <a:lstStyle xmlns:a="http://schemas.openxmlformats.org/drawingml/2006/main"/>
           <a:p xmlns:a="http://schemas.openxmlformats.org/drawingml/2006/main">
             <a:pPr>
+              <a:buNone/>
               <a:defRPr sz="1275" b="1">
                 <a:solidFill>
                   <a:srgbClr val="006C70"/>
@@ -20708,6 +20966,7 @@
           <a:lstStyle xmlns:a="http://schemas.openxmlformats.org/drawingml/2006/main"/>
           <a:p xmlns:a="http://schemas.openxmlformats.org/drawingml/2006/main">
             <a:pPr>
+              <a:buNone/>
               <a:defRPr sz="1290" b="0">
                 <a:solidFill>
                   <a:srgbClr val="153040"/>
@@ -20765,6 +21024,7 @@
           <a:lstStyle xmlns:a="http://schemas.openxmlformats.org/drawingml/2006/main"/>
           <a:p xmlns:a="http://schemas.openxmlformats.org/drawingml/2006/main">
             <a:pPr>
+              <a:buNone/>
               <a:defRPr sz="1275" b="1">
                 <a:solidFill>
                   <a:srgbClr val="006C70"/>
@@ -20822,6 +21082,7 @@
           <a:lstStyle xmlns:a="http://schemas.openxmlformats.org/drawingml/2006/main"/>
           <a:p xmlns:a="http://schemas.openxmlformats.org/drawingml/2006/main">
             <a:pPr>
+              <a:buNone/>
               <a:defRPr sz="1290" b="0">
                 <a:solidFill>
                   <a:srgbClr val="153040"/>
@@ -20879,6 +21140,7 @@
           <a:lstStyle xmlns:a="http://schemas.openxmlformats.org/drawingml/2006/main"/>
           <a:p xmlns:a="http://schemas.openxmlformats.org/drawingml/2006/main">
             <a:pPr>
+              <a:buNone/>
               <a:defRPr sz="1275" b="1">
                 <a:solidFill>
                   <a:srgbClr val="006C70"/>
@@ -20936,6 +21198,7 @@
           <a:lstStyle xmlns:a="http://schemas.openxmlformats.org/drawingml/2006/main"/>
           <a:p xmlns:a="http://schemas.openxmlformats.org/drawingml/2006/main">
             <a:pPr>
+              <a:buNone/>
               <a:defRPr sz="1290" b="0">
                 <a:solidFill>
                   <a:srgbClr val="153040"/>
@@ -21023,6 +21286,7 @@
           <a:lstStyle xmlns:a="http://schemas.openxmlformats.org/drawingml/2006/main"/>
           <a:p xmlns:a="http://schemas.openxmlformats.org/drawingml/2006/main">
             <a:pPr>
+              <a:buNone/>
               <a:defRPr sz="1125" b="0">
                 <a:solidFill>
                   <a:srgbClr val="526872"/>
@@ -21080,6 +21344,7 @@
           <a:lstStyle xmlns:a="http://schemas.openxmlformats.org/drawingml/2006/main"/>
           <a:p xmlns:a="http://schemas.openxmlformats.org/drawingml/2006/main">
             <a:pPr>
+              <a:buNone/>
               <a:defRPr sz="1275" b="0">
                 <a:solidFill>
                   <a:srgbClr val="526872"/>
@@ -21166,6 +21431,7 @@
           <a:lstStyle xmlns:a="http://schemas.openxmlformats.org/drawingml/2006/main"/>
           <a:p xmlns:a="http://schemas.openxmlformats.org/drawingml/2006/main">
             <a:pPr>
+              <a:buNone/>
               <a:defRPr sz="1350" b="1">
                 <a:solidFill>
                   <a:srgbClr val="006C70"/>
@@ -21223,6 +21489,7 @@
           <a:lstStyle xmlns:a="http://schemas.openxmlformats.org/drawingml/2006/main"/>
           <a:p xmlns:a="http://schemas.openxmlformats.org/drawingml/2006/main">
             <a:pPr>
+              <a:buNone/>
               <a:defRPr sz="3225" b="1">
                 <a:solidFill>
                   <a:srgbClr val="153040"/>
@@ -21280,6 +21547,7 @@
           <a:lstStyle xmlns:a="http://schemas.openxmlformats.org/drawingml/2006/main"/>
           <a:p xmlns:a="http://schemas.openxmlformats.org/drawingml/2006/main">
             <a:pPr>
+              <a:buNone/>
               <a:defRPr sz="2025" b="0">
                 <a:solidFill>
                   <a:srgbClr val="526872"/>
@@ -21337,6 +21605,7 @@
           <a:lstStyle xmlns:a="http://schemas.openxmlformats.org/drawingml/2006/main"/>
           <a:p xmlns:a="http://schemas.openxmlformats.org/drawingml/2006/main">
             <a:pPr>
+              <a:buNone/>
               <a:defRPr sz="2025" b="1">
                 <a:solidFill>
                   <a:srgbClr val="006C70"/>
@@ -21394,6 +21663,7 @@
           <a:lstStyle xmlns:a="http://schemas.openxmlformats.org/drawingml/2006/main"/>
           <a:p xmlns:a="http://schemas.openxmlformats.org/drawingml/2006/main">
             <a:pPr>
+              <a:buNone/>
               <a:defRPr sz="2100" b="0">
                 <a:solidFill>
                   <a:srgbClr val="153040"/>
@@ -21481,6 +21751,7 @@
           <a:lstStyle xmlns:a="http://schemas.openxmlformats.org/drawingml/2006/main"/>
           <a:p xmlns:a="http://schemas.openxmlformats.org/drawingml/2006/main">
             <a:pPr>
+              <a:buNone/>
               <a:defRPr sz="2025" b="1">
                 <a:solidFill>
                   <a:srgbClr val="006C70"/>
@@ -21538,6 +21809,7 @@
           <a:lstStyle xmlns:a="http://schemas.openxmlformats.org/drawingml/2006/main"/>
           <a:p xmlns:a="http://schemas.openxmlformats.org/drawingml/2006/main">
             <a:pPr>
+              <a:buNone/>
               <a:defRPr sz="2100" b="0">
                 <a:solidFill>
                   <a:srgbClr val="153040"/>
@@ -21625,6 +21897,7 @@
           <a:lstStyle xmlns:a="http://schemas.openxmlformats.org/drawingml/2006/main"/>
           <a:p xmlns:a="http://schemas.openxmlformats.org/drawingml/2006/main">
             <a:pPr>
+              <a:buNone/>
               <a:defRPr sz="2025" b="1">
                 <a:solidFill>
                   <a:srgbClr val="006C70"/>
@@ -21682,6 +21955,7 @@
           <a:lstStyle xmlns:a="http://schemas.openxmlformats.org/drawingml/2006/main"/>
           <a:p xmlns:a="http://schemas.openxmlformats.org/drawingml/2006/main">
             <a:pPr>
+              <a:buNone/>
               <a:defRPr sz="2100" b="0">
                 <a:solidFill>
                   <a:srgbClr val="153040"/>
@@ -21769,6 +22043,7 @@
           <a:lstStyle xmlns:a="http://schemas.openxmlformats.org/drawingml/2006/main"/>
           <a:p xmlns:a="http://schemas.openxmlformats.org/drawingml/2006/main">
             <a:pPr>
+              <a:buNone/>
               <a:defRPr sz="1125" b="0">
                 <a:solidFill>
                   <a:srgbClr val="526872"/>
@@ -21826,6 +22101,7 @@
           <a:lstStyle xmlns:a="http://schemas.openxmlformats.org/drawingml/2006/main"/>
           <a:p xmlns:a="http://schemas.openxmlformats.org/drawingml/2006/main">
             <a:pPr>
+              <a:buNone/>
               <a:defRPr sz="1275" b="0">
                 <a:solidFill>
                   <a:srgbClr val="526872"/>
@@ -21912,6 +22188,7 @@
           <a:lstStyle xmlns:a="http://schemas.openxmlformats.org/drawingml/2006/main"/>
           <a:p xmlns:a="http://schemas.openxmlformats.org/drawingml/2006/main">
             <a:pPr>
+              <a:buNone/>
               <a:defRPr sz="1350" b="1">
                 <a:solidFill>
                   <a:srgbClr val="006C70"/>
@@ -21969,6 +22246,7 @@
           <a:lstStyle xmlns:a="http://schemas.openxmlformats.org/drawingml/2006/main"/>
           <a:p xmlns:a="http://schemas.openxmlformats.org/drawingml/2006/main">
             <a:pPr>
+              <a:buNone/>
               <a:defRPr sz="3225" b="1">
                 <a:solidFill>
                   <a:srgbClr val="153040"/>
@@ -22026,6 +22304,7 @@
           <a:lstStyle xmlns:a="http://schemas.openxmlformats.org/drawingml/2006/main"/>
           <a:p xmlns:a="http://schemas.openxmlformats.org/drawingml/2006/main">
             <a:pPr>
+              <a:buNone/>
               <a:defRPr sz="2025" b="0">
                 <a:solidFill>
                   <a:srgbClr val="526872"/>
@@ -22083,6 +22362,7 @@
           <a:lstStyle xmlns:a="http://schemas.openxmlformats.org/drawingml/2006/main"/>
           <a:p xmlns:a="http://schemas.openxmlformats.org/drawingml/2006/main">
             <a:pPr>
+              <a:buNone/>
               <a:defRPr sz="2025" b="1">
                 <a:solidFill>
                   <a:srgbClr val="006C70"/>
@@ -22140,6 +22420,7 @@
           <a:lstStyle xmlns:a="http://schemas.openxmlformats.org/drawingml/2006/main"/>
           <a:p xmlns:a="http://schemas.openxmlformats.org/drawingml/2006/main">
             <a:pPr>
+              <a:buNone/>
               <a:defRPr sz="2100" b="0">
                 <a:solidFill>
                   <a:srgbClr val="153040"/>
@@ -22227,6 +22508,7 @@
           <a:lstStyle xmlns:a="http://schemas.openxmlformats.org/drawingml/2006/main"/>
           <a:p xmlns:a="http://schemas.openxmlformats.org/drawingml/2006/main">
             <a:pPr>
+              <a:buNone/>
               <a:defRPr sz="2025" b="1">
                 <a:solidFill>
                   <a:srgbClr val="006C70"/>
@@ -22284,6 +22566,7 @@
           <a:lstStyle xmlns:a="http://schemas.openxmlformats.org/drawingml/2006/main"/>
           <a:p xmlns:a="http://schemas.openxmlformats.org/drawingml/2006/main">
             <a:pPr>
+              <a:buNone/>
               <a:defRPr sz="2100" b="0">
                 <a:solidFill>
                   <a:srgbClr val="153040"/>
@@ -22371,6 +22654,7 @@
           <a:lstStyle xmlns:a="http://schemas.openxmlformats.org/drawingml/2006/main"/>
           <a:p xmlns:a="http://schemas.openxmlformats.org/drawingml/2006/main">
             <a:pPr>
+              <a:buNone/>
               <a:defRPr sz="2025" b="1">
                 <a:solidFill>
                   <a:srgbClr val="006C70"/>
@@ -22428,6 +22712,7 @@
           <a:lstStyle xmlns:a="http://schemas.openxmlformats.org/drawingml/2006/main"/>
           <a:p xmlns:a="http://schemas.openxmlformats.org/drawingml/2006/main">
             <a:pPr>
+              <a:buNone/>
               <a:defRPr sz="2100" b="0">
                 <a:solidFill>
                   <a:srgbClr val="153040"/>
@@ -22515,6 +22800,7 @@
           <a:lstStyle xmlns:a="http://schemas.openxmlformats.org/drawingml/2006/main"/>
           <a:p xmlns:a="http://schemas.openxmlformats.org/drawingml/2006/main">
             <a:pPr>
+              <a:buNone/>
               <a:defRPr sz="1125" b="0">
                 <a:solidFill>
                   <a:srgbClr val="526872"/>
@@ -22572,6 +22858,7 @@
           <a:lstStyle xmlns:a="http://schemas.openxmlformats.org/drawingml/2006/main"/>
           <a:p xmlns:a="http://schemas.openxmlformats.org/drawingml/2006/main">
             <a:pPr>
+              <a:buNone/>
               <a:defRPr sz="1275" b="0">
                 <a:solidFill>
                   <a:srgbClr val="526872"/>
@@ -22658,6 +22945,7 @@
           <a:lstStyle xmlns:a="http://schemas.openxmlformats.org/drawingml/2006/main"/>
           <a:p xmlns:a="http://schemas.openxmlformats.org/drawingml/2006/main">
             <a:pPr>
+              <a:buNone/>
               <a:defRPr sz="1350" b="1">
                 <a:solidFill>
                   <a:srgbClr val="006C70"/>
@@ -22715,6 +23003,7 @@
           <a:lstStyle xmlns:a="http://schemas.openxmlformats.org/drawingml/2006/main"/>
           <a:p xmlns:a="http://schemas.openxmlformats.org/drawingml/2006/main">
             <a:pPr>
+              <a:buNone/>
               <a:defRPr sz="3225" b="1">
                 <a:solidFill>
                   <a:srgbClr val="153040"/>
@@ -22772,6 +23061,7 @@
           <a:lstStyle xmlns:a="http://schemas.openxmlformats.org/drawingml/2006/main"/>
           <a:p xmlns:a="http://schemas.openxmlformats.org/drawingml/2006/main">
             <a:pPr>
+              <a:buNone/>
               <a:defRPr sz="2025" b="0">
                 <a:solidFill>
                   <a:srgbClr val="526872"/>
@@ -22797,7 +23087,7 @@
       </p:sp>
       <p:graphicFrame>
         <p:nvGraphicFramePr>
-          <p:cNvPr id="11" name=""/>
+          <p:cNvPr id="13" name=""/>
           <p:cNvGraphicFramePr/>
           <p:nvPr/>
         </p:nvGraphicFramePr>
@@ -23282,6 +23572,7 @@
           <a:lstStyle xmlns:a="http://schemas.openxmlformats.org/drawingml/2006/main"/>
           <a:p xmlns:a="http://schemas.openxmlformats.org/drawingml/2006/main">
             <a:pPr>
+              <a:buNone/>
               <a:defRPr sz="1125" b="0">
                 <a:solidFill>
                   <a:srgbClr val="526872"/>
@@ -23339,6 +23630,7 @@
           <a:lstStyle xmlns:a="http://schemas.openxmlformats.org/drawingml/2006/main"/>
           <a:p xmlns:a="http://schemas.openxmlformats.org/drawingml/2006/main">
             <a:pPr>
+              <a:buNone/>
               <a:defRPr sz="1275" b="0">
                 <a:solidFill>
                   <a:srgbClr val="526872"/>
@@ -23425,6 +23717,7 @@
           <a:lstStyle xmlns:a="http://schemas.openxmlformats.org/drawingml/2006/main"/>
           <a:p xmlns:a="http://schemas.openxmlformats.org/drawingml/2006/main">
             <a:pPr>
+              <a:buNone/>
               <a:defRPr sz="1350" b="1">
                 <a:solidFill>
                   <a:srgbClr val="006C70"/>
@@ -23482,6 +23775,7 @@
           <a:lstStyle xmlns:a="http://schemas.openxmlformats.org/drawingml/2006/main"/>
           <a:p xmlns:a="http://schemas.openxmlformats.org/drawingml/2006/main">
             <a:pPr>
+              <a:buNone/>
               <a:defRPr sz="3225" b="1">
                 <a:solidFill>
                   <a:srgbClr val="153040"/>
@@ -23539,6 +23833,7 @@
           <a:lstStyle xmlns:a="http://schemas.openxmlformats.org/drawingml/2006/main"/>
           <a:p xmlns:a="http://schemas.openxmlformats.org/drawingml/2006/main">
             <a:pPr>
+              <a:buNone/>
               <a:defRPr sz="2025" b="0">
                 <a:solidFill>
                   <a:srgbClr val="526872"/>
@@ -23596,6 +23891,7 @@
           <a:lstStyle xmlns:a="http://schemas.openxmlformats.org/drawingml/2006/main"/>
           <a:p xmlns:a="http://schemas.openxmlformats.org/drawingml/2006/main">
             <a:pPr>
+              <a:buNone/>
               <a:defRPr sz="2025" b="1">
                 <a:solidFill>
                   <a:srgbClr val="006C70"/>
@@ -23653,6 +23949,7 @@
           <a:lstStyle xmlns:a="http://schemas.openxmlformats.org/drawingml/2006/main"/>
           <a:p xmlns:a="http://schemas.openxmlformats.org/drawingml/2006/main">
             <a:pPr>
+              <a:buNone/>
               <a:defRPr sz="2100" b="0">
                 <a:solidFill>
                   <a:srgbClr val="153040"/>
@@ -23740,6 +24037,7 @@
           <a:lstStyle xmlns:a="http://schemas.openxmlformats.org/drawingml/2006/main"/>
           <a:p xmlns:a="http://schemas.openxmlformats.org/drawingml/2006/main">
             <a:pPr>
+              <a:buNone/>
               <a:defRPr sz="2025" b="1">
                 <a:solidFill>
                   <a:srgbClr val="006C70"/>
@@ -23797,6 +24095,7 @@
           <a:lstStyle xmlns:a="http://schemas.openxmlformats.org/drawingml/2006/main"/>
           <a:p xmlns:a="http://schemas.openxmlformats.org/drawingml/2006/main">
             <a:pPr>
+              <a:buNone/>
               <a:defRPr sz="2100" b="0">
                 <a:solidFill>
                   <a:srgbClr val="153040"/>
@@ -23884,6 +24183,7 @@
           <a:lstStyle xmlns:a="http://schemas.openxmlformats.org/drawingml/2006/main"/>
           <a:p xmlns:a="http://schemas.openxmlformats.org/drawingml/2006/main">
             <a:pPr>
+              <a:buNone/>
               <a:defRPr sz="2025" b="1">
                 <a:solidFill>
                   <a:srgbClr val="006C70"/>
@@ -23941,6 +24241,7 @@
           <a:lstStyle xmlns:a="http://schemas.openxmlformats.org/drawingml/2006/main"/>
           <a:p xmlns:a="http://schemas.openxmlformats.org/drawingml/2006/main">
             <a:pPr>
+              <a:buNone/>
               <a:defRPr sz="2100" b="0">
                 <a:solidFill>
                   <a:srgbClr val="153040"/>
@@ -24028,6 +24329,7 @@
           <a:lstStyle xmlns:a="http://schemas.openxmlformats.org/drawingml/2006/main"/>
           <a:p xmlns:a="http://schemas.openxmlformats.org/drawingml/2006/main">
             <a:pPr>
+              <a:buNone/>
               <a:defRPr sz="1125" b="0">
                 <a:solidFill>
                   <a:srgbClr val="526872"/>
@@ -24085,6 +24387,7 @@
           <a:lstStyle xmlns:a="http://schemas.openxmlformats.org/drawingml/2006/main"/>
           <a:p xmlns:a="http://schemas.openxmlformats.org/drawingml/2006/main">
             <a:pPr>
+              <a:buNone/>
               <a:defRPr sz="1275" b="0">
                 <a:solidFill>
                   <a:srgbClr val="526872"/>
@@ -24171,6 +24474,7 @@
           <a:lstStyle xmlns:a="http://schemas.openxmlformats.org/drawingml/2006/main"/>
           <a:p xmlns:a="http://schemas.openxmlformats.org/drawingml/2006/main">
             <a:pPr>
+              <a:buNone/>
               <a:defRPr sz="1350" b="1">
                 <a:solidFill>
                   <a:srgbClr val="006C70"/>
@@ -24228,6 +24532,7 @@
           <a:lstStyle xmlns:a="http://schemas.openxmlformats.org/drawingml/2006/main"/>
           <a:p xmlns:a="http://schemas.openxmlformats.org/drawingml/2006/main">
             <a:pPr>
+              <a:buNone/>
               <a:defRPr sz="3225" b="1">
                 <a:solidFill>
                   <a:srgbClr val="153040"/>
@@ -24285,6 +24590,7 @@
           <a:lstStyle xmlns:a="http://schemas.openxmlformats.org/drawingml/2006/main"/>
           <a:p xmlns:a="http://schemas.openxmlformats.org/drawingml/2006/main">
             <a:pPr>
+              <a:buNone/>
               <a:defRPr sz="2025" b="0">
                 <a:solidFill>
                   <a:srgbClr val="526872"/>
@@ -24342,6 +24648,7 @@
           <a:lstStyle xmlns:a="http://schemas.openxmlformats.org/drawingml/2006/main"/>
           <a:p xmlns:a="http://schemas.openxmlformats.org/drawingml/2006/main">
             <a:pPr>
+              <a:buNone/>
               <a:defRPr sz="2025" b="1">
                 <a:solidFill>
                   <a:srgbClr val="006C70"/>
@@ -24399,6 +24706,7 @@
           <a:lstStyle xmlns:a="http://schemas.openxmlformats.org/drawingml/2006/main"/>
           <a:p xmlns:a="http://schemas.openxmlformats.org/drawingml/2006/main">
             <a:pPr>
+              <a:buNone/>
               <a:defRPr sz="2100" b="0">
                 <a:solidFill>
                   <a:srgbClr val="153040"/>
@@ -24486,6 +24794,7 @@
           <a:lstStyle xmlns:a="http://schemas.openxmlformats.org/drawingml/2006/main"/>
           <a:p xmlns:a="http://schemas.openxmlformats.org/drawingml/2006/main">
             <a:pPr>
+              <a:buNone/>
               <a:defRPr sz="2025" b="1">
                 <a:solidFill>
                   <a:srgbClr val="006C70"/>
@@ -24543,6 +24852,7 @@
           <a:lstStyle xmlns:a="http://schemas.openxmlformats.org/drawingml/2006/main"/>
           <a:p xmlns:a="http://schemas.openxmlformats.org/drawingml/2006/main">
             <a:pPr>
+              <a:buNone/>
               <a:defRPr sz="2100" b="0">
                 <a:solidFill>
                   <a:srgbClr val="153040"/>
@@ -24630,6 +24940,7 @@
           <a:lstStyle xmlns:a="http://schemas.openxmlformats.org/drawingml/2006/main"/>
           <a:p xmlns:a="http://schemas.openxmlformats.org/drawingml/2006/main">
             <a:pPr>
+              <a:buNone/>
               <a:defRPr sz="2025" b="1">
                 <a:solidFill>
                   <a:srgbClr val="006C70"/>
@@ -24687,6 +24998,7 @@
           <a:lstStyle xmlns:a="http://schemas.openxmlformats.org/drawingml/2006/main"/>
           <a:p xmlns:a="http://schemas.openxmlformats.org/drawingml/2006/main">
             <a:pPr>
+              <a:buNone/>
               <a:defRPr sz="2100" b="0">
                 <a:solidFill>
                   <a:srgbClr val="153040"/>
@@ -24774,6 +25086,7 @@
           <a:lstStyle xmlns:a="http://schemas.openxmlformats.org/drawingml/2006/main"/>
           <a:p xmlns:a="http://schemas.openxmlformats.org/drawingml/2006/main">
             <a:pPr>
+              <a:buNone/>
               <a:defRPr sz="1125" b="0">
                 <a:solidFill>
                   <a:srgbClr val="526872"/>
@@ -24831,6 +25144,7 @@
           <a:lstStyle xmlns:a="http://schemas.openxmlformats.org/drawingml/2006/main"/>
           <a:p xmlns:a="http://schemas.openxmlformats.org/drawingml/2006/main">
             <a:pPr>
+              <a:buNone/>
               <a:defRPr sz="1275" b="0">
                 <a:solidFill>
                   <a:srgbClr val="526872"/>
@@ -24917,6 +25231,7 @@
           <a:lstStyle xmlns:a="http://schemas.openxmlformats.org/drawingml/2006/main"/>
           <a:p xmlns:a="http://schemas.openxmlformats.org/drawingml/2006/main">
             <a:pPr>
+              <a:buNone/>
               <a:defRPr sz="1350" b="1">
                 <a:solidFill>
                   <a:srgbClr val="006C70"/>
@@ -24974,6 +25289,7 @@
           <a:lstStyle xmlns:a="http://schemas.openxmlformats.org/drawingml/2006/main"/>
           <a:p xmlns:a="http://schemas.openxmlformats.org/drawingml/2006/main">
             <a:pPr>
+              <a:buNone/>
               <a:defRPr sz="3225" b="1">
                 <a:solidFill>
                   <a:srgbClr val="153040"/>
@@ -25031,6 +25347,7 @@
           <a:lstStyle xmlns:a="http://schemas.openxmlformats.org/drawingml/2006/main"/>
           <a:p xmlns:a="http://schemas.openxmlformats.org/drawingml/2006/main">
             <a:pPr>
+              <a:buNone/>
               <a:defRPr sz="2025" b="0">
                 <a:solidFill>
                   <a:srgbClr val="526872"/>
@@ -25088,6 +25405,7 @@
           <a:lstStyle xmlns:a="http://schemas.openxmlformats.org/drawingml/2006/main"/>
           <a:p xmlns:a="http://schemas.openxmlformats.org/drawingml/2006/main">
             <a:pPr>
+              <a:buNone/>
               <a:defRPr sz="2025" b="1">
                 <a:solidFill>
                   <a:srgbClr val="006C70"/>
@@ -25145,6 +25463,7 @@
           <a:lstStyle xmlns:a="http://schemas.openxmlformats.org/drawingml/2006/main"/>
           <a:p xmlns:a="http://schemas.openxmlformats.org/drawingml/2006/main">
             <a:pPr>
+              <a:buNone/>
               <a:defRPr sz="2100" b="0">
                 <a:solidFill>
                   <a:srgbClr val="153040"/>
@@ -25232,6 +25551,7 @@
           <a:lstStyle xmlns:a="http://schemas.openxmlformats.org/drawingml/2006/main"/>
           <a:p xmlns:a="http://schemas.openxmlformats.org/drawingml/2006/main">
             <a:pPr>
+              <a:buNone/>
               <a:defRPr sz="2025" b="1">
                 <a:solidFill>
                   <a:srgbClr val="006C70"/>
@@ -25289,6 +25609,7 @@
           <a:lstStyle xmlns:a="http://schemas.openxmlformats.org/drawingml/2006/main"/>
           <a:p xmlns:a="http://schemas.openxmlformats.org/drawingml/2006/main">
             <a:pPr>
+              <a:buNone/>
               <a:defRPr sz="2100" b="0">
                 <a:solidFill>
                   <a:srgbClr val="153040"/>
@@ -25376,6 +25697,7 @@
           <a:lstStyle xmlns:a="http://schemas.openxmlformats.org/drawingml/2006/main"/>
           <a:p xmlns:a="http://schemas.openxmlformats.org/drawingml/2006/main">
             <a:pPr>
+              <a:buNone/>
               <a:defRPr sz="2025" b="1">
                 <a:solidFill>
                   <a:srgbClr val="006C70"/>
@@ -25433,6 +25755,7 @@
           <a:lstStyle xmlns:a="http://schemas.openxmlformats.org/drawingml/2006/main"/>
           <a:p xmlns:a="http://schemas.openxmlformats.org/drawingml/2006/main">
             <a:pPr>
+              <a:buNone/>
               <a:defRPr sz="2100" b="0">
                 <a:solidFill>
                   <a:srgbClr val="153040"/>
@@ -25520,6 +25843,7 @@
           <a:lstStyle xmlns:a="http://schemas.openxmlformats.org/drawingml/2006/main"/>
           <a:p xmlns:a="http://schemas.openxmlformats.org/drawingml/2006/main">
             <a:pPr>
+              <a:buNone/>
               <a:defRPr sz="1125" b="0">
                 <a:solidFill>
                   <a:srgbClr val="526872"/>
@@ -25577,6 +25901,7 @@
           <a:lstStyle xmlns:a="http://schemas.openxmlformats.org/drawingml/2006/main"/>
           <a:p xmlns:a="http://schemas.openxmlformats.org/drawingml/2006/main">
             <a:pPr>
+              <a:buNone/>
               <a:defRPr sz="1275" b="0">
                 <a:solidFill>
                   <a:srgbClr val="526872"/>
@@ -25663,6 +25988,7 @@
           <a:lstStyle xmlns:a="http://schemas.openxmlformats.org/drawingml/2006/main"/>
           <a:p xmlns:a="http://schemas.openxmlformats.org/drawingml/2006/main">
             <a:pPr>
+              <a:buNone/>
               <a:defRPr sz="1350" b="1">
                 <a:solidFill>
                   <a:srgbClr val="006C70"/>
@@ -25720,6 +26046,7 @@
           <a:lstStyle xmlns:a="http://schemas.openxmlformats.org/drawingml/2006/main"/>
           <a:p xmlns:a="http://schemas.openxmlformats.org/drawingml/2006/main">
             <a:pPr>
+              <a:buNone/>
               <a:defRPr sz="3225" b="1">
                 <a:solidFill>
                   <a:srgbClr val="153040"/>
@@ -25777,6 +26104,7 @@
           <a:lstStyle xmlns:a="http://schemas.openxmlformats.org/drawingml/2006/main"/>
           <a:p xmlns:a="http://schemas.openxmlformats.org/drawingml/2006/main">
             <a:pPr>
+              <a:buNone/>
               <a:defRPr sz="2025" b="0">
                 <a:solidFill>
                   <a:srgbClr val="526872"/>
@@ -25802,7 +26130,7 @@
       </p:sp>
       <p:graphicFrame>
         <p:nvGraphicFramePr>
-          <p:cNvPr id="11" name=""/>
+          <p:cNvPr id="13" name=""/>
           <p:cNvGraphicFramePr/>
           <p:nvPr/>
         </p:nvGraphicFramePr>
@@ -26207,6 +26535,7 @@
           <a:lstStyle xmlns:a="http://schemas.openxmlformats.org/drawingml/2006/main"/>
           <a:p xmlns:a="http://schemas.openxmlformats.org/drawingml/2006/main">
             <a:pPr>
+              <a:buNone/>
               <a:defRPr sz="1125" b="0">
                 <a:solidFill>
                   <a:srgbClr val="526872"/>
@@ -26264,6 +26593,7 @@
           <a:lstStyle xmlns:a="http://schemas.openxmlformats.org/drawingml/2006/main"/>
           <a:p xmlns:a="http://schemas.openxmlformats.org/drawingml/2006/main">
             <a:pPr>
+              <a:buNone/>
               <a:defRPr sz="1275" b="0">
                 <a:solidFill>
                   <a:srgbClr val="526872"/>

</xml_diff>

<commit_message>
fix(imaging): remove manual review eligibility gates
</commit_message>
<xml_diff>
--- a/presentations/CNSRIII_Hcy_WMH_假设驱动统计方案_v2.pptx
+++ b/presentations/CNSRIII_Hcy_WMH_假设驱动统计方案_v2.pptx
@@ -2,40 +2,40 @@
 <file path=ppt/presentation.xml><?xml version="1.0" encoding="utf-8"?>
 <p:presentation xmlns:p="http://schemas.openxmlformats.org/presentationml/2006/main">
   <p:sldMasterIdLst>
-    <p:sldMasterId xmlns:r="http://schemas.openxmlformats.org/officeDocument/2006/relationships" id="2147483648" r:id="R75539f5dcfda43d0"/>
+    <p:sldMasterId xmlns:r="http://schemas.openxmlformats.org/officeDocument/2006/relationships" id="2147483648" r:id="Rec6f06643eef4403"/>
   </p:sldMasterIdLst>
   <p:notesMasterIdLst>
-    <p:notesMasterId xmlns:r="http://schemas.openxmlformats.org/officeDocument/2006/relationships" r:id="R1bc4252b7d394a61"/>
+    <p:notesMasterId xmlns:r="http://schemas.openxmlformats.org/officeDocument/2006/relationships" r:id="R504a86f407134526"/>
   </p:notesMasterIdLst>
   <p:sldIdLst>
-    <p:sldId xmlns:r="http://schemas.openxmlformats.org/officeDocument/2006/relationships" id="256" r:id="R758851baa59b4589"/>
-    <p:sldId xmlns:r="http://schemas.openxmlformats.org/officeDocument/2006/relationships" id="257" r:id="R7c5c7cd4476c4b3c"/>
-    <p:sldId xmlns:r="http://schemas.openxmlformats.org/officeDocument/2006/relationships" id="258" r:id="R6e787cd4244c40fe"/>
-    <p:sldId xmlns:r="http://schemas.openxmlformats.org/officeDocument/2006/relationships" id="259" r:id="R05d6b92b766b4834"/>
-    <p:sldId xmlns:r="http://schemas.openxmlformats.org/officeDocument/2006/relationships" id="260" r:id="R6e742b7a92754ce7"/>
-    <p:sldId xmlns:r="http://schemas.openxmlformats.org/officeDocument/2006/relationships" id="261" r:id="Rdc0090f2250944de"/>
-    <p:sldId xmlns:r="http://schemas.openxmlformats.org/officeDocument/2006/relationships" id="262" r:id="R8b5bdaf4e2f84278"/>
-    <p:sldId xmlns:r="http://schemas.openxmlformats.org/officeDocument/2006/relationships" id="263" r:id="R8eee6b0ddb7840d2"/>
-    <p:sldId xmlns:r="http://schemas.openxmlformats.org/officeDocument/2006/relationships" id="264" r:id="Rf6eae2bd6a234563"/>
-    <p:sldId xmlns:r="http://schemas.openxmlformats.org/officeDocument/2006/relationships" id="265" r:id="Rd4e2c4971fb34f23"/>
-    <p:sldId xmlns:r="http://schemas.openxmlformats.org/officeDocument/2006/relationships" id="266" r:id="R6ddbe45af022492a"/>
-    <p:sldId xmlns:r="http://schemas.openxmlformats.org/officeDocument/2006/relationships" id="267" r:id="R146df45574ae43bf"/>
-    <p:sldId xmlns:r="http://schemas.openxmlformats.org/officeDocument/2006/relationships" id="268" r:id="R90a5b06ac5484427"/>
-    <p:sldId xmlns:r="http://schemas.openxmlformats.org/officeDocument/2006/relationships" id="269" r:id="R708edbe6fc1d4389"/>
-    <p:sldId xmlns:r="http://schemas.openxmlformats.org/officeDocument/2006/relationships" id="270" r:id="R6f3d0612d04a4827"/>
-    <p:sldId xmlns:r="http://schemas.openxmlformats.org/officeDocument/2006/relationships" id="271" r:id="R9d522d5ec6b74b86"/>
-    <p:sldId xmlns:r="http://schemas.openxmlformats.org/officeDocument/2006/relationships" id="272" r:id="R4c37a5690ff94e4c"/>
-    <p:sldId xmlns:r="http://schemas.openxmlformats.org/officeDocument/2006/relationships" id="273" r:id="R4970e3fa12a34ebd"/>
-    <p:sldId xmlns:r="http://schemas.openxmlformats.org/officeDocument/2006/relationships" id="274" r:id="Rb436cde82bdc4247"/>
-    <p:sldId xmlns:r="http://schemas.openxmlformats.org/officeDocument/2006/relationships" id="275" r:id="Rd240df7afb254df4"/>
-    <p:sldId xmlns:r="http://schemas.openxmlformats.org/officeDocument/2006/relationships" id="276" r:id="Rc3e92f0dd4604706"/>
-    <p:sldId xmlns:r="http://schemas.openxmlformats.org/officeDocument/2006/relationships" id="277" r:id="R15629b87660f4e30"/>
-    <p:sldId xmlns:r="http://schemas.openxmlformats.org/officeDocument/2006/relationships" id="278" r:id="R29c527bbbb864684"/>
-    <p:sldId xmlns:r="http://schemas.openxmlformats.org/officeDocument/2006/relationships" id="279" r:id="R2d0bfb5332f84fd4"/>
-    <p:sldId xmlns:r="http://schemas.openxmlformats.org/officeDocument/2006/relationships" id="280" r:id="Rccd0a979953d472e"/>
-    <p:sldId xmlns:r="http://schemas.openxmlformats.org/officeDocument/2006/relationships" id="281" r:id="Rcc738dbc73d54ec8"/>
-    <p:sldId xmlns:r="http://schemas.openxmlformats.org/officeDocument/2006/relationships" id="282" r:id="R90acb4183da04a40"/>
-    <p:sldId xmlns:r="http://schemas.openxmlformats.org/officeDocument/2006/relationships" id="283" r:id="R84dc2cc4e8b14a12"/>
+    <p:sldId xmlns:r="http://schemas.openxmlformats.org/officeDocument/2006/relationships" id="256" r:id="R213551f1ea8c4797"/>
+    <p:sldId xmlns:r="http://schemas.openxmlformats.org/officeDocument/2006/relationships" id="257" r:id="Rc99db153ed1a4702"/>
+    <p:sldId xmlns:r="http://schemas.openxmlformats.org/officeDocument/2006/relationships" id="258" r:id="R32246195c96e46b1"/>
+    <p:sldId xmlns:r="http://schemas.openxmlformats.org/officeDocument/2006/relationships" id="259" r:id="R41e8a1a76189412e"/>
+    <p:sldId xmlns:r="http://schemas.openxmlformats.org/officeDocument/2006/relationships" id="260" r:id="Rde09d216b6674efd"/>
+    <p:sldId xmlns:r="http://schemas.openxmlformats.org/officeDocument/2006/relationships" id="261" r:id="R67742b97577b4b1e"/>
+    <p:sldId xmlns:r="http://schemas.openxmlformats.org/officeDocument/2006/relationships" id="262" r:id="R9b4b128a8d9a49b5"/>
+    <p:sldId xmlns:r="http://schemas.openxmlformats.org/officeDocument/2006/relationships" id="263" r:id="Re53423c4ff1c4e52"/>
+    <p:sldId xmlns:r="http://schemas.openxmlformats.org/officeDocument/2006/relationships" id="264" r:id="R24dc4c13a88a4912"/>
+    <p:sldId xmlns:r="http://schemas.openxmlformats.org/officeDocument/2006/relationships" id="265" r:id="Rb8b0b6021a144b17"/>
+    <p:sldId xmlns:r="http://schemas.openxmlformats.org/officeDocument/2006/relationships" id="266" r:id="R630351f02d1d4fbf"/>
+    <p:sldId xmlns:r="http://schemas.openxmlformats.org/officeDocument/2006/relationships" id="267" r:id="R606c1bf2a4124b43"/>
+    <p:sldId xmlns:r="http://schemas.openxmlformats.org/officeDocument/2006/relationships" id="268" r:id="Rd673caca5c944257"/>
+    <p:sldId xmlns:r="http://schemas.openxmlformats.org/officeDocument/2006/relationships" id="269" r:id="R80a2b4c966c6431e"/>
+    <p:sldId xmlns:r="http://schemas.openxmlformats.org/officeDocument/2006/relationships" id="270" r:id="R807b24f1bc1a422a"/>
+    <p:sldId xmlns:r="http://schemas.openxmlformats.org/officeDocument/2006/relationships" id="271" r:id="R31beec1f668a4539"/>
+    <p:sldId xmlns:r="http://schemas.openxmlformats.org/officeDocument/2006/relationships" id="272" r:id="R134bdbc98836449d"/>
+    <p:sldId xmlns:r="http://schemas.openxmlformats.org/officeDocument/2006/relationships" id="273" r:id="R792afe83f8064b19"/>
+    <p:sldId xmlns:r="http://schemas.openxmlformats.org/officeDocument/2006/relationships" id="274" r:id="R31fa261efbca4077"/>
+    <p:sldId xmlns:r="http://schemas.openxmlformats.org/officeDocument/2006/relationships" id="275" r:id="Rca134079f23b41c4"/>
+    <p:sldId xmlns:r="http://schemas.openxmlformats.org/officeDocument/2006/relationships" id="276" r:id="R22b8003fdae64b6b"/>
+    <p:sldId xmlns:r="http://schemas.openxmlformats.org/officeDocument/2006/relationships" id="277" r:id="R13b71e5414534889"/>
+    <p:sldId xmlns:r="http://schemas.openxmlformats.org/officeDocument/2006/relationships" id="278" r:id="Rdd8fdfc6ce594ebc"/>
+    <p:sldId xmlns:r="http://schemas.openxmlformats.org/officeDocument/2006/relationships" id="279" r:id="R8fcc1bbe366c404c"/>
+    <p:sldId xmlns:r="http://schemas.openxmlformats.org/officeDocument/2006/relationships" id="280" r:id="Re5c65aa203a24a85"/>
+    <p:sldId xmlns:r="http://schemas.openxmlformats.org/officeDocument/2006/relationships" id="281" r:id="R88cacc6475ac4498"/>
+    <p:sldId xmlns:r="http://schemas.openxmlformats.org/officeDocument/2006/relationships" id="282" r:id="R9cdd96dfbd604646"/>
+    <p:sldId xmlns:r="http://schemas.openxmlformats.org/officeDocument/2006/relationships" id="283" r:id="R1f8b70b76a5f48a4"/>
   </p:sldIdLst>
   <p:sldSz cx="12192000" cy="6858000"/>
   <p:notesSz cx="6858000" cy="9144000"/>
@@ -752,6 +752,16 @@
               <a:t/>
             </a:r>
           </a:p>
+          <a:p xmlns:a="http://schemas.openxmlformats.org/drawingml/2006/main">
+            <a:r>
+              <a:t/>
+            </a:r>
+          </a:p>
+          <a:p xmlns:a="http://schemas.openxmlformats.org/drawingml/2006/main">
+            <a:r>
+              <a:t>入组不要求影像人工质控。按WMH、ICV及各子分析体积的数值可用性选择病例，保留文件、单位和ID检查。已有审核标签不参与筛选。</a:t>
+            </a:r>
+          </a:p>
         </p:txBody>
       </p:sp>
       <p:sp>
@@ -839,7 +849,7 @@
           </a:p>
           <a:p xmlns:a="http://schemas.openxmlformats.org/drawingml/2006/main">
             <a:r>
-              <a:t>2026-09-16：以发病为时间尺度，从实际基线采血日进入风险集。发病到MRI的天数不再作为输入或筛选条件。合格MRI视为基线结构表型，本分析不核定扫描与早期复发的先后。</a:t>
+              <a:t>2026-09-16：以发病为时间尺度，从实际基线采血日进入风险集。发病到MRI的天数不再作为输入或筛选条件。MRI产出视为基线结构表型，本分析不核定扫描与早期复发的先后。</a:t>
             </a:r>
           </a:p>
         </p:txBody>
@@ -3007,7 +3017,7 @@
   </p:cSld>
   <p:clrMap bg1="lt1" tx1="dk1" bg2="lt2" tx2="dk2" accent1="accent1" accent2="accent2" accent3="accent3" accent4="accent4" accent5="accent5" accent6="accent6" hlink="hlink" folHlink="folHlink"/>
   <p:sldLayoutIdLst>
-    <p:sldLayoutId xmlns:r="http://schemas.openxmlformats.org/officeDocument/2006/relationships" id="2147483649" r:id="R580b0a5b76644145"/>
+    <p:sldLayoutId xmlns:r="http://schemas.openxmlformats.org/officeDocument/2006/relationships" id="2147483649" r:id="Rf7eab5dd0d4f46ad"/>
   </p:sldLayoutIdLst>
   <p:txStyles>
     <p:titleStyle>
@@ -5553,7 +5563,7 @@
       </p:sp>
       <p:cxnSp>
         <p:nvCxnSpPr>
-          <p:cNvPr id="45" name=""/>
+          <p:cNvPr id="61" name=""/>
           <p:cNvCxnSpPr>
             <a:stCxn xmlns:a="http://schemas.openxmlformats.org/drawingml/2006/main" id="4" idx="1"/>
             <a:endCxn xmlns:a="http://schemas.openxmlformats.org/drawingml/2006/main" id="5" idx="0"/>
@@ -5578,7 +5588,7 @@
       </p:cxnSp>
       <p:cxnSp>
         <p:nvCxnSpPr>
-          <p:cNvPr id="46" name=""/>
+          <p:cNvPr id="62" name=""/>
           <p:cNvCxnSpPr>
             <a:stCxn xmlns:a="http://schemas.openxmlformats.org/drawingml/2006/main" id="4" idx="1"/>
             <a:endCxn xmlns:a="http://schemas.openxmlformats.org/drawingml/2006/main" id="6" idx="1"/>
@@ -5603,7 +5613,7 @@
       </p:cxnSp>
       <p:cxnSp>
         <p:nvCxnSpPr>
-          <p:cNvPr id="47" name=""/>
+          <p:cNvPr id="63" name=""/>
           <p:cNvCxnSpPr>
             <a:stCxn xmlns:a="http://schemas.openxmlformats.org/drawingml/2006/main" id="4" idx="3"/>
             <a:endCxn xmlns:a="http://schemas.openxmlformats.org/drawingml/2006/main" id="8" idx="0"/>
@@ -5628,7 +5638,7 @@
       </p:cxnSp>
       <p:cxnSp>
         <p:nvCxnSpPr>
-          <p:cNvPr id="48" name=""/>
+          <p:cNvPr id="64" name=""/>
           <p:cNvCxnSpPr>
             <a:stCxn xmlns:a="http://schemas.openxmlformats.org/drawingml/2006/main" id="5" idx="3"/>
             <a:endCxn xmlns:a="http://schemas.openxmlformats.org/drawingml/2006/main" id="8" idx="1"/>
@@ -5653,7 +5663,7 @@
       </p:cxnSp>
       <p:cxnSp>
         <p:nvCxnSpPr>
-          <p:cNvPr id="49" name=""/>
+          <p:cNvPr id="65" name=""/>
           <p:cNvCxnSpPr>
             <a:stCxn xmlns:a="http://schemas.openxmlformats.org/drawingml/2006/main" id="6" idx="3"/>
             <a:endCxn xmlns:a="http://schemas.openxmlformats.org/drawingml/2006/main" id="8" idx="2"/>
@@ -5678,7 +5688,7 @@
       </p:cxnSp>
       <p:cxnSp>
         <p:nvCxnSpPr>
-          <p:cNvPr id="50" name=""/>
+          <p:cNvPr id="66" name=""/>
           <p:cNvCxnSpPr>
             <a:stCxn xmlns:a="http://schemas.openxmlformats.org/drawingml/2006/main" id="5" idx="2"/>
             <a:endCxn xmlns:a="http://schemas.openxmlformats.org/drawingml/2006/main" id="7" idx="1"/>
@@ -5703,7 +5713,7 @@
       </p:cxnSp>
       <p:cxnSp>
         <p:nvCxnSpPr>
-          <p:cNvPr id="51" name=""/>
+          <p:cNvPr id="67" name=""/>
           <p:cNvCxnSpPr>
             <a:stCxn xmlns:a="http://schemas.openxmlformats.org/drawingml/2006/main" id="6" idx="3"/>
             <a:endCxn xmlns:a="http://schemas.openxmlformats.org/drawingml/2006/main" id="7" idx="1"/>
@@ -5728,7 +5738,7 @@
       </p:cxnSp>
       <p:cxnSp>
         <p:nvCxnSpPr>
-          <p:cNvPr id="52" name=""/>
+          <p:cNvPr id="68" name=""/>
           <p:cNvCxnSpPr>
             <a:stCxn xmlns:a="http://schemas.openxmlformats.org/drawingml/2006/main" id="7" idx="3"/>
             <a:endCxn xmlns:a="http://schemas.openxmlformats.org/drawingml/2006/main" id="8" idx="2"/>
@@ -6215,7 +6225,7 @@
                 <a:ea typeface="Microsoft YaHei"/>
                 <a:cs typeface="Microsoft YaHei"/>
               </a:rPr>
-              <a:t>输入与质控</a:t>
+              <a:t>数据接入</a:t>
             </a:r>
           </a:p>
         </p:txBody>
@@ -6342,7 +6352,7 @@
       </p:sp>
       <p:cxnSp>
         <p:nvCxnSpPr>
-          <p:cNvPr id="43" name=""/>
+          <p:cNvPr id="59" name=""/>
           <p:cNvCxnSpPr>
             <a:stCxn xmlns:a="http://schemas.openxmlformats.org/drawingml/2006/main" id="4" idx="2"/>
             <a:endCxn xmlns:a="http://schemas.openxmlformats.org/drawingml/2006/main" id="6" idx="0"/>
@@ -6487,7 +6497,7 @@
       </p:sp>
       <p:cxnSp>
         <p:nvCxnSpPr>
-          <p:cNvPr id="46" name=""/>
+          <p:cNvPr id="62" name=""/>
           <p:cNvCxnSpPr>
             <a:stCxn xmlns:a="http://schemas.openxmlformats.org/drawingml/2006/main" id="6" idx="2"/>
             <a:endCxn xmlns:a="http://schemas.openxmlformats.org/drawingml/2006/main" id="9" idx="0"/>
@@ -6632,7 +6642,7 @@
       </p:sp>
       <p:cxnSp>
         <p:nvCxnSpPr>
-          <p:cNvPr id="49" name=""/>
+          <p:cNvPr id="65" name=""/>
           <p:cNvCxnSpPr>
             <a:stCxn xmlns:a="http://schemas.openxmlformats.org/drawingml/2006/main" id="9" idx="2"/>
             <a:endCxn xmlns:a="http://schemas.openxmlformats.org/drawingml/2006/main" id="12" idx="0"/>
@@ -6777,7 +6787,7 @@
       </p:sp>
       <p:cxnSp>
         <p:nvCxnSpPr>
-          <p:cNvPr id="52" name=""/>
+          <p:cNvPr id="68" name=""/>
           <p:cNvCxnSpPr>
             <a:stCxn xmlns:a="http://schemas.openxmlformats.org/drawingml/2006/main" id="12" idx="2"/>
             <a:endCxn xmlns:a="http://schemas.openxmlformats.org/drawingml/2006/main" id="15" idx="0"/>
@@ -7449,7 +7459,7 @@
       </p:sp>
       <p:cxnSp>
         <p:nvCxnSpPr>
-          <p:cNvPr id="42" name=""/>
+          <p:cNvPr id="56" name=""/>
           <p:cNvCxnSpPr>
             <a:stCxn xmlns:a="http://schemas.openxmlformats.org/drawingml/2006/main" id="4" idx="3"/>
             <a:endCxn xmlns:a="http://schemas.openxmlformats.org/drawingml/2006/main" id="6" idx="1"/>
@@ -7594,7 +7604,7 @@
       </p:sp>
       <p:cxnSp>
         <p:nvCxnSpPr>
-          <p:cNvPr id="45" name=""/>
+          <p:cNvPr id="59" name=""/>
           <p:cNvCxnSpPr>
             <a:stCxn xmlns:a="http://schemas.openxmlformats.org/drawingml/2006/main" id="6" idx="3"/>
             <a:endCxn xmlns:a="http://schemas.openxmlformats.org/drawingml/2006/main" id="9" idx="1"/>
@@ -7739,7 +7749,7 @@
       </p:sp>
       <p:cxnSp>
         <p:nvCxnSpPr>
-          <p:cNvPr id="48" name=""/>
+          <p:cNvPr id="62" name=""/>
           <p:cNvCxnSpPr>
             <a:stCxn xmlns:a="http://schemas.openxmlformats.org/drawingml/2006/main" id="9" idx="3"/>
             <a:endCxn xmlns:a="http://schemas.openxmlformats.org/drawingml/2006/main" id="12" idx="1"/>
@@ -14585,7 +14595,7 @@
                 <a:ea typeface="Microsoft YaHei"/>
                 <a:cs typeface="Microsoft YaHei"/>
               </a:rPr>
-              <a:t>在合格子样本加入GM119灰质总体积，报告条件关联。</a:t>
+              <a:t>在T1体积可用者中加入GM119灰质总体积，报告条件关联。</a:t>
             </a:r>
           </a:p>
         </p:txBody>
@@ -16026,7 +16036,7 @@
       </p:sp>
       <p:cxnSp>
         <p:nvCxnSpPr>
-          <p:cNvPr id="37" name=""/>
+          <p:cNvPr id="50" name=""/>
           <p:cNvCxnSpPr>
             <a:stCxn xmlns:a="http://schemas.openxmlformats.org/drawingml/2006/main" id="4" idx="2"/>
             <a:endCxn xmlns:a="http://schemas.openxmlformats.org/drawingml/2006/main" id="6" idx="0"/>
@@ -16171,7 +16181,7 @@
       </p:sp>
       <p:cxnSp>
         <p:nvCxnSpPr>
-          <p:cNvPr id="40" name=""/>
+          <p:cNvPr id="53" name=""/>
           <p:cNvCxnSpPr>
             <a:stCxn xmlns:a="http://schemas.openxmlformats.org/drawingml/2006/main" id="6" idx="2"/>
             <a:endCxn xmlns:a="http://schemas.openxmlformats.org/drawingml/2006/main" id="9" idx="0"/>
@@ -16316,7 +16326,7 @@
       </p:sp>
       <p:cxnSp>
         <p:nvCxnSpPr>
-          <p:cNvPr id="43" name=""/>
+          <p:cNvPr id="56" name=""/>
           <p:cNvCxnSpPr>
             <a:stCxn xmlns:a="http://schemas.openxmlformats.org/drawingml/2006/main" id="9" idx="2"/>
             <a:endCxn xmlns:a="http://schemas.openxmlformats.org/drawingml/2006/main" id="12" idx="0"/>

</xml_diff>